<commit_message>
Actualización de dependencias y mejoras en la lógica y UI
</commit_message>
<xml_diff>
--- a/Exposicion_GaussJordan.pptx
+++ b/Exposicion_GaussJordan.pptx
@@ -4,6 +4,9 @@
   <p:sldMasterIdLst>
     <p:sldMasterId id="2147483648" r:id="rId1"/>
   </p:sldMasterIdLst>
+  <p:notesMasterIdLst>
+    <p:notesMasterId r:id="rId13"/>
+  </p:notesMasterIdLst>
   <p:sldIdLst>
     <p:sldId id="256" r:id="rId2"/>
     <p:sldId id="257" r:id="rId3"/>
@@ -17,10 +20,7 @@
     <p:sldId id="265" r:id="rId11"/>
     <p:sldId id="266" r:id="rId12"/>
   </p:sldIdLst>
-  <p:notesMasterIdLst>
-    <p:notesMasterId r:id="rId13"/>
-  </p:notesMasterIdLst>
-  <p:sldSz cx="9144000" cy="5143500"/>
+  <p:sldSz cx="9144000" cy="5143500" type="screen16x9"/>
   <p:notesSz cx="5143500" cy="9144000"/>
   <p:defaultTextStyle>
     <a:lvl1pPr marL="0" algn="l" defTabSz="914400" rtl="0" eaLnBrk="1" latinLnBrk="0" hangingPunct="1">
@@ -114,7 +114,81 @@
       </a:defRPr>
     </a:lvl9pPr>
   </p:defaultTextStyle>
+  <p:extLst>
+    <p:ext uri="{EFAFB233-063F-42B5-8137-9DF3F51BA10A}">
+      <p15:sldGuideLst xmlns:p15="http://schemas.microsoft.com/office/powerpoint/2012/main"/>
+    </p:ext>
+  </p:extLst>
 </p:presentation>
+</file>
+
+<file path=ppt/changesInfos/changesInfo1.xml><?xml version="1.0" encoding="utf-8"?>
+<pc:chgInfo xmlns:a="http://schemas.openxmlformats.org/drawingml/2006/main" xmlns:r="http://schemas.openxmlformats.org/officeDocument/2006/relationships" xmlns:ac="http://schemas.microsoft.com/office/drawing/2013/main/command" xmlns:pc="http://schemas.microsoft.com/office/powerpoint/2013/main/command">
+  <pc:docChgLst>
+    <pc:chgData name="Diego Robles" userId="4cdd6e01cc07b61c" providerId="LiveId" clId="{0875EDC9-6195-4DB0-B359-730F42285D39}"/>
+    <pc:docChg chg="undo custSel modSld">
+      <pc:chgData name="Diego Robles" userId="4cdd6e01cc07b61c" providerId="LiveId" clId="{0875EDC9-6195-4DB0-B359-730F42285D39}" dt="2026-04-10T14:57:26.270" v="31" actId="20577"/>
+      <pc:docMkLst>
+        <pc:docMk/>
+      </pc:docMkLst>
+      <pc:sldChg chg="modSp mod">
+        <pc:chgData name="Diego Robles" userId="4cdd6e01cc07b61c" providerId="LiveId" clId="{0875EDC9-6195-4DB0-B359-730F42285D39}" dt="2026-04-10T14:57:26.270" v="31" actId="20577"/>
+        <pc:sldMkLst>
+          <pc:docMk/>
+          <pc:sldMk cId="0" sldId="256"/>
+        </pc:sldMkLst>
+        <pc:spChg chg="mod">
+          <ac:chgData name="Diego Robles" userId="4cdd6e01cc07b61c" providerId="LiveId" clId="{0875EDC9-6195-4DB0-B359-730F42285D39}" dt="2026-04-10T14:57:24.633" v="30" actId="1076"/>
+          <ac:spMkLst>
+            <pc:docMk/>
+            <pc:sldMk cId="0" sldId="256"/>
+            <ac:spMk id="3" creationId="{00000000-0000-0000-0000-000000000000}"/>
+          </ac:spMkLst>
+        </pc:spChg>
+        <pc:spChg chg="mod">
+          <ac:chgData name="Diego Robles" userId="4cdd6e01cc07b61c" providerId="LiveId" clId="{0875EDC9-6195-4DB0-B359-730F42285D39}" dt="2026-04-10T14:57:20.140" v="29" actId="20577"/>
+          <ac:spMkLst>
+            <pc:docMk/>
+            <pc:sldMk cId="0" sldId="256"/>
+            <ac:spMk id="8" creationId="{00000000-0000-0000-0000-000000000000}"/>
+          </ac:spMkLst>
+        </pc:spChg>
+        <pc:spChg chg="mod">
+          <ac:chgData name="Diego Robles" userId="4cdd6e01cc07b61c" providerId="LiveId" clId="{0875EDC9-6195-4DB0-B359-730F42285D39}" dt="2026-04-10T14:56:56.187" v="17" actId="20577"/>
+          <ac:spMkLst>
+            <pc:docMk/>
+            <pc:sldMk cId="0" sldId="256"/>
+            <ac:spMk id="12" creationId="{00000000-0000-0000-0000-000000000000}"/>
+          </ac:spMkLst>
+        </pc:spChg>
+        <pc:spChg chg="mod">
+          <ac:chgData name="Diego Robles" userId="4cdd6e01cc07b61c" providerId="LiveId" clId="{0875EDC9-6195-4DB0-B359-730F42285D39}" dt="2026-04-10T14:57:07.712" v="23" actId="20577"/>
+          <ac:spMkLst>
+            <pc:docMk/>
+            <pc:sldMk cId="0" sldId="256"/>
+            <ac:spMk id="13" creationId="{00000000-0000-0000-0000-000000000000}"/>
+          </ac:spMkLst>
+        </pc:spChg>
+        <pc:spChg chg="mod">
+          <ac:chgData name="Diego Robles" userId="4cdd6e01cc07b61c" providerId="LiveId" clId="{0875EDC9-6195-4DB0-B359-730F42285D39}" dt="2026-04-10T14:57:05.044" v="22" actId="20577"/>
+          <ac:spMkLst>
+            <pc:docMk/>
+            <pc:sldMk cId="0" sldId="256"/>
+            <ac:spMk id="14" creationId="{00000000-0000-0000-0000-000000000000}"/>
+          </ac:spMkLst>
+        </pc:spChg>
+        <pc:spChg chg="mod">
+          <ac:chgData name="Diego Robles" userId="4cdd6e01cc07b61c" providerId="LiveId" clId="{0875EDC9-6195-4DB0-B359-730F42285D39}" dt="2026-04-10T14:57:26.270" v="31" actId="20577"/>
+          <ac:spMkLst>
+            <pc:docMk/>
+            <pc:sldMk cId="0" sldId="256"/>
+            <ac:spMk id="15" creationId="{00000000-0000-0000-0000-000000000000}"/>
+          </ac:spMkLst>
+        </pc:spChg>
+      </pc:sldChg>
+    </pc:docChg>
+  </pc:docChgLst>
+</pc:chgInfo>
 </file>
 
 <file path=ppt/notesMasters/notesMaster1.xml><?xml version="1.0" encoding="utf-8"?>
@@ -139,234 +213,10 @@
           <a:chExt cx="0" cy="0"/>
         </a:xfrm>
       </p:grpSpPr>
-      <p:sp>
-        <p:nvSpPr>
-          <p:cNvPr id="2" name="Header Placeholder 1"/>
-          <p:cNvSpPr>
-            <a:spLocks noGrp="1"/>
-          </p:cNvSpPr>
-          <p:nvPr>
-            <p:ph type="hdr" sz="quarter"/>
-          </p:nvPr>
-        </p:nvSpPr>
-        <p:spPr>
-          <a:xfrm>
-            <a:off x="0" y="0"/>
-            <a:ext cx="2971800" cy="458788"/>
-          </a:xfrm>
-          <a:prstGeom prst="rect">
-            <a:avLst/>
-          </a:prstGeom>
-        </p:spPr>
-        <p:txBody>
-          <a:bodyPr vert="horz" lIns="91440" tIns="45720" rIns="91440" bIns="45720" rtlCol="0"/>
-          <a:lstStyle>
-            <a:lvl1pPr algn="l">
-              <a:defRPr sz="1200"/>
-            </a:lvl1pPr>
-          </a:lstStyle>
-          <a:p>
-            <a:endParaRPr lang="en-US"/>
-          </a:p>
-        </p:txBody>
-      </p:sp>
-      <p:sp>
-        <p:nvSpPr>
-          <p:cNvPr id="3" name="Date Placeholder 2"/>
-          <p:cNvSpPr>
-            <a:spLocks noGrp="1"/>
-          </p:cNvSpPr>
-          <p:nvPr>
-            <p:ph type="dt" idx="1"/>
-          </p:nvPr>
-        </p:nvSpPr>
-        <p:spPr>
-          <a:xfrm>
-            <a:off x="3884613" y="0"/>
-            <a:ext cx="2971800" cy="458788"/>
-          </a:xfrm>
-          <a:prstGeom prst="rect">
-            <a:avLst/>
-          </a:prstGeom>
-        </p:spPr>
-        <p:txBody>
-          <a:bodyPr vert="horz" lIns="91440" tIns="45720" rIns="91440" bIns="45720" rtlCol="0"/>
-          <a:lstStyle>
-            <a:lvl1pPr algn="r">
-              <a:defRPr sz="1200"/>
-            </a:lvl1pPr>
-          </a:lstStyle>
-          <a:p>
-            <a:fld id="{5282F153-3F37-0F45-9E97-73ACFA13230C}" type="datetimeFigureOut">
-              <a:rPr lang="en-US"/>
-              <a:t>7/23/19</a:t>
-            </a:fld>
-            <a:endParaRPr lang="en-US"/>
-          </a:p>
-        </p:txBody>
-      </p:sp>
-      <p:sp>
-        <p:nvSpPr>
-          <p:cNvPr id="4" name="Slide Image Placeholder 3"/>
-          <p:cNvSpPr>
-            <a:spLocks noGrp="1" noRot="1" noChangeAspect="1"/>
-          </p:cNvSpPr>
-          <p:nvPr>
-            <p:ph type="sldImg" idx="2"/>
-          </p:nvPr>
-        </p:nvSpPr>
-        <p:spPr>
-          <a:xfrm>
-            <a:off x="685800" y="1143000"/>
-            <a:ext cx="5486400" cy="3086100"/>
-          </a:xfrm>
-          <a:prstGeom prst="rect">
-            <a:avLst/>
-          </a:prstGeom>
-          <a:noFill/>
-          <a:ln w="12700">
-            <a:solidFill>
-              <a:prstClr val="black"/>
-            </a:solidFill>
-          </a:ln>
-        </p:spPr>
-        <p:txBody>
-          <a:bodyPr vert="horz" lIns="91440" tIns="45720" rIns="91440" bIns="45720" rtlCol="0" anchor="ctr"/>
-          <a:lstStyle/>
-          <a:p>
-            <a:endParaRPr lang="en-US"/>
-          </a:p>
-        </p:txBody>
-      </p:sp>
-      <p:sp>
-        <p:nvSpPr>
-          <p:cNvPr id="5" name="Notes Placeholder 4"/>
-          <p:cNvSpPr>
-            <a:spLocks noGrp="1"/>
-          </p:cNvSpPr>
-          <p:nvPr>
-            <p:ph type="body" sz="quarter" idx="3"/>
-          </p:nvPr>
-        </p:nvSpPr>
-        <p:spPr>
-          <a:xfrm>
-            <a:off x="685800" y="4400550"/>
-            <a:ext cx="5486400" cy="3600450"/>
-          </a:xfrm>
-          <a:prstGeom prst="rect">
-            <a:avLst/>
-          </a:prstGeom>
-        </p:spPr>
-        <p:txBody>
-          <a:bodyPr vert="horz" lIns="91440" tIns="45720" rIns="91440" bIns="45720" rtlCol="0"/>
-          <a:lstStyle/>
-          <a:p>
-            <a:pPr lvl="0"/>
-            <a:r>
-              <a:rPr lang="en-US"/>
-              <a:t>Click to edit Master text styles</a:t>
-            </a:r>
-          </a:p>
-          <a:p>
-            <a:pPr lvl="1"/>
-            <a:r>
-              <a:rPr lang="en-US"/>
-              <a:t>Second level</a:t>
-            </a:r>
-          </a:p>
-          <a:p>
-            <a:pPr lvl="2"/>
-            <a:r>
-              <a:rPr lang="en-US"/>
-              <a:t>Third level</a:t>
-            </a:r>
-          </a:p>
-          <a:p>
-            <a:pPr lvl="3"/>
-            <a:r>
-              <a:rPr lang="en-US"/>
-              <a:t>Fourth level</a:t>
-            </a:r>
-          </a:p>
-          <a:p>
-            <a:pPr lvl="4"/>
-            <a:r>
-              <a:rPr lang="en-US"/>
-              <a:t>Fifth level</a:t>
-            </a:r>
-          </a:p>
-        </p:txBody>
-      </p:sp>
-      <p:sp>
-        <p:nvSpPr>
-          <p:cNvPr id="6" name="Footer Placeholder 5"/>
-          <p:cNvSpPr>
-            <a:spLocks noGrp="1"/>
-          </p:cNvSpPr>
-          <p:nvPr>
-            <p:ph type="ftr" sz="quarter" idx="4"/>
-          </p:nvPr>
-        </p:nvSpPr>
-        <p:spPr>
-          <a:xfrm>
-            <a:off x="0" y="8685213"/>
-            <a:ext cx="2971800" cy="458787"/>
-          </a:xfrm>
-          <a:prstGeom prst="rect">
-            <a:avLst/>
-          </a:prstGeom>
-        </p:spPr>
-        <p:txBody>
-          <a:bodyPr vert="horz" lIns="91440" tIns="45720" rIns="91440" bIns="45720" rtlCol="0" anchor="b"/>
-          <a:lstStyle>
-            <a:lvl1pPr algn="l">
-              <a:defRPr sz="1200"/>
-            </a:lvl1pPr>
-          </a:lstStyle>
-          <a:p>
-            <a:endParaRPr lang="en-US"/>
-          </a:p>
-        </p:txBody>
-      </p:sp>
-      <p:sp>
-        <p:nvSpPr>
-          <p:cNvPr id="7" name="Slide Number Placeholder 6"/>
-          <p:cNvSpPr>
-            <a:spLocks noGrp="1"/>
-          </p:cNvSpPr>
-          <p:nvPr>
-            <p:ph type="sldNum" sz="quarter" idx="5"/>
-          </p:nvPr>
-        </p:nvSpPr>
-        <p:spPr>
-          <a:xfrm>
-            <a:off x="3884613" y="8685213"/>
-            <a:ext cx="2971800" cy="458787"/>
-          </a:xfrm>
-          <a:prstGeom prst="rect">
-            <a:avLst/>
-          </a:prstGeom>
-        </p:spPr>
-        <p:txBody>
-          <a:bodyPr vert="horz" lIns="91440" tIns="45720" rIns="91440" bIns="45720" rtlCol="0" anchor="b"/>
-          <a:lstStyle>
-            <a:lvl1pPr algn="r">
-              <a:defRPr sz="1200"/>
-            </a:lvl1pPr>
-          </a:lstStyle>
-          <a:p>
-            <a:fld id="{CE5E9CC1-C706-0F49-92D6-E571CC5EEA8F}" type="slidenum">
-              <a:rPr lang="en-US"/>
-              <a:t>‹#›</a:t>
-            </a:fld>
-            <a:endParaRPr lang="en-US"/>
-          </a:p>
-        </p:txBody>
-      </p:sp>
     </p:spTree>
     <p:extLst>
       <p:ext uri="{BB962C8B-B14F-4D97-AF65-F5344CB8AC3E}">
-        <p14:creationId xmlns:p14="http://schemas.microsoft.com/office/powerpoint/2010/main" val="1024086991"/>
+        <p14:creationId xmlns:p14="http://schemas.microsoft.com/office/powerpoint/2010/main" val="516848559"/>
       </p:ext>
     </p:extLst>
   </p:cSld>
@@ -510,10 +360,6 @@
           <a:bodyPr/>
           <a:lstStyle/>
           <a:p>
-            <a:r>
-              <a:rPr lang="en-US" dirty="0"/>
-              <a:t/>
-            </a:r>
             <a:endParaRPr lang="en-US" dirty="0"/>
           </a:p>
         </p:txBody>
@@ -598,10 +444,6 @@
           <a:bodyPr/>
           <a:lstStyle/>
           <a:p>
-            <a:r>
-              <a:rPr lang="en-US" dirty="0"/>
-              <a:t/>
-            </a:r>
             <a:endParaRPr lang="en-US" dirty="0"/>
           </a:p>
         </p:txBody>
@@ -686,10 +528,6 @@
           <a:bodyPr/>
           <a:lstStyle/>
           <a:p>
-            <a:r>
-              <a:rPr lang="en-US" dirty="0"/>
-              <a:t/>
-            </a:r>
             <a:endParaRPr lang="en-US" dirty="0"/>
           </a:p>
         </p:txBody>
@@ -774,10 +612,6 @@
           <a:bodyPr/>
           <a:lstStyle/>
           <a:p>
-            <a:r>
-              <a:rPr lang="en-US" dirty="0"/>
-              <a:t/>
-            </a:r>
             <a:endParaRPr lang="en-US" dirty="0"/>
           </a:p>
         </p:txBody>
@@ -862,10 +696,6 @@
           <a:bodyPr/>
           <a:lstStyle/>
           <a:p>
-            <a:r>
-              <a:rPr lang="en-US" dirty="0"/>
-              <a:t/>
-            </a:r>
             <a:endParaRPr lang="en-US" dirty="0"/>
           </a:p>
         </p:txBody>
@@ -950,10 +780,6 @@
           <a:bodyPr/>
           <a:lstStyle/>
           <a:p>
-            <a:r>
-              <a:rPr lang="en-US" dirty="0"/>
-              <a:t/>
-            </a:r>
             <a:endParaRPr lang="en-US" dirty="0"/>
           </a:p>
         </p:txBody>
@@ -1038,10 +864,6 @@
           <a:bodyPr/>
           <a:lstStyle/>
           <a:p>
-            <a:r>
-              <a:rPr lang="en-US" dirty="0"/>
-              <a:t/>
-            </a:r>
             <a:endParaRPr lang="en-US" dirty="0"/>
           </a:p>
         </p:txBody>
@@ -1126,10 +948,6 @@
           <a:bodyPr/>
           <a:lstStyle/>
           <a:p>
-            <a:r>
-              <a:rPr lang="en-US" dirty="0"/>
-              <a:t/>
-            </a:r>
             <a:endParaRPr lang="en-US" dirty="0"/>
           </a:p>
         </p:txBody>
@@ -1214,10 +1032,6 @@
           <a:bodyPr/>
           <a:lstStyle/>
           <a:p>
-            <a:r>
-              <a:rPr lang="en-US" dirty="0"/>
-              <a:t/>
-            </a:r>
             <a:endParaRPr lang="en-US" dirty="0"/>
           </a:p>
         </p:txBody>
@@ -1302,10 +1116,6 @@
           <a:bodyPr/>
           <a:lstStyle/>
           <a:p>
-            <a:r>
-              <a:rPr lang="en-US" dirty="0"/>
-              <a:t/>
-            </a:r>
             <a:endParaRPr lang="en-US" dirty="0"/>
           </a:p>
         </p:txBody>
@@ -1390,10 +1200,6 @@
           <a:bodyPr/>
           <a:lstStyle/>
           <a:p>
-            <a:r>
-              <a:rPr lang="en-US" dirty="0"/>
-              <a:t/>
-            </a:r>
             <a:endParaRPr lang="en-US" dirty="0"/>
           </a:p>
         </p:txBody>
@@ -1467,6 +1273,11 @@
 <file path=ppt/slideMasters/slideMaster1.xml><?xml version="1.0" encoding="utf-8"?>
 <p:sldMaster xmlns:a="http://schemas.openxmlformats.org/drawingml/2006/main" xmlns:r="http://schemas.openxmlformats.org/officeDocument/2006/relationships" xmlns:p="http://schemas.openxmlformats.org/presentationml/2006/main">
   <p:cSld>
+    <p:bg>
+      <p:bgRef idx="1001">
+        <a:schemeClr val="bg1"/>
+      </p:bgRef>
+    </p:bg>
     <p:spTree>
       <p:nvGrpSpPr>
         <p:cNvPr id="1" name=""/>
@@ -1782,6 +1593,13 @@
             <a:prstDash val="solid"/>
           </a:ln>
         </p:spPr>
+        <p:txBody>
+          <a:bodyPr/>
+          <a:lstStyle/>
+          <a:p>
+            <a:endParaRPr lang="es-CO"/>
+          </a:p>
+        </p:txBody>
       </p:sp>
       <p:sp>
         <p:nvSpPr>
@@ -1791,7 +1609,7 @@
         </p:nvSpPr>
         <p:spPr>
           <a:xfrm>
-            <a:off x="4754880" y="0"/>
+            <a:off x="4773168" y="-11430"/>
             <a:ext cx="4389120" cy="5143500"/>
           </a:xfrm>
           <a:prstGeom prst="rect">
@@ -1807,6 +1625,13 @@
             <a:prstDash val="solid"/>
           </a:ln>
         </p:spPr>
+        <p:txBody>
+          <a:bodyPr/>
+          <a:lstStyle/>
+          <a:p>
+            <a:endParaRPr lang="es-CO"/>
+          </a:p>
+        </p:txBody>
       </p:sp>
       <p:sp>
         <p:nvSpPr>
@@ -1832,6 +1657,13 @@
             <a:prstDash val="solid"/>
           </a:ln>
         </p:spPr>
+        <p:txBody>
+          <a:bodyPr/>
+          <a:lstStyle/>
+          <a:p>
+            <a:endParaRPr lang="es-CO"/>
+          </a:p>
+        </p:txBody>
       </p:sp>
       <p:sp>
         <p:nvSpPr>
@@ -1854,7 +1686,7 @@
           <a:bodyPr wrap="square" rtlCol="0" anchor="ctr"/>
           <a:lstStyle/>
           <a:p>
-            <a:pPr indent="0" marL="0">
+            <a:pPr marL="0" indent="0">
               <a:buNone/>
             </a:pPr>
             <a:r>
@@ -1871,7 +1703,7 @@
             <a:endParaRPr lang="en-US" sz="3800" dirty="0"/>
           </a:p>
           <a:p>
-            <a:pPr indent="0" marL="0">
+            <a:pPr marL="0" indent="0">
               <a:buNone/>
             </a:pPr>
             <a:r>
@@ -1910,7 +1742,7 @@
           <a:bodyPr wrap="square" rtlCol="0" anchor="t"/>
           <a:lstStyle/>
           <a:p>
-            <a:pPr indent="0" marL="0">
+            <a:pPr marL="0" indent="0">
               <a:buNone/>
             </a:pPr>
             <a:r>
@@ -1927,7 +1759,7 @@
             <a:endParaRPr lang="en-US" sz="1400" dirty="0"/>
           </a:p>
           <a:p>
-            <a:pPr indent="0" marL="0">
+            <a:pPr marL="0" indent="0">
               <a:buNone/>
             </a:pPr>
             <a:r>
@@ -1966,7 +1798,7 @@
           <a:bodyPr wrap="square" rtlCol="0" anchor="ctr"/>
           <a:lstStyle/>
           <a:p>
-            <a:pPr indent="0" marL="0">
+            <a:pPr marL="0" indent="0">
               <a:buNone/>
             </a:pPr>
             <a:r>
@@ -2005,7 +1837,7 @@
           <a:bodyPr wrap="square" rtlCol="0" anchor="t"/>
           <a:lstStyle/>
           <a:p>
-            <a:pPr indent="0" marL="0">
+            <a:pPr marL="0" indent="0">
               <a:buNone/>
             </a:pPr>
             <a:r>
@@ -2022,7 +1854,7 @@
             <a:endParaRPr lang="en-US" sz="1300" dirty="0"/>
           </a:p>
           <a:p>
-            <a:pPr indent="0" marL="0">
+            <a:pPr marL="0" indent="0">
               <a:buNone/>
             </a:pPr>
             <a:r>
@@ -2034,7 +1866,7 @@
                 <a:ea typeface="Open Sans" pitchFamily="34" charset="-122"/>
                 <a:cs typeface="Open Sans" pitchFamily="34" charset="-120"/>
               </a:rPr>
-              <a:t>Santander Ocana</a:t>
+              <a:t>Santander Ocaña</a:t>
             </a:r>
             <a:endParaRPr lang="en-US" sz="1300" dirty="0"/>
           </a:p>
@@ -2061,7 +1893,7 @@
           <a:bodyPr wrap="square" rtlCol="0" anchor="ctr"/>
           <a:lstStyle/>
           <a:p>
-            <a:pPr indent="0" marL="0">
+            <a:pPr marL="0" indent="0">
               <a:buNone/>
             </a:pPr>
             <a:r>
@@ -2103,6 +1935,13 @@
             <a:prstDash val="solid"/>
           </a:ln>
         </p:spPr>
+        <p:txBody>
+          <a:bodyPr/>
+          <a:lstStyle/>
+          <a:p>
+            <a:endParaRPr lang="es-CO"/>
+          </a:p>
+        </p:txBody>
       </p:sp>
       <p:sp>
         <p:nvSpPr>
@@ -2125,7 +1964,7 @@
           <a:bodyPr wrap="square" rtlCol="0" anchor="ctr"/>
           <a:lstStyle/>
           <a:p>
-            <a:pPr indent="0" marL="0">
+            <a:pPr marL="0" indent="0">
               <a:buNone/>
             </a:pPr>
             <a:r>
@@ -2164,7 +2003,7 @@
           <a:bodyPr wrap="square" rtlCol="0" anchor="ctr"/>
           <a:lstStyle/>
           <a:p>
-            <a:pPr indent="0" marL="0">
+            <a:pPr marL="0" indent="0">
               <a:buNone/>
             </a:pPr>
             <a:r>
@@ -2176,12 +2015,12 @@
                 <a:ea typeface="Open Sans" pitchFamily="34" charset="-122"/>
                 <a:cs typeface="Open Sans" pitchFamily="34" charset="-120"/>
               </a:rPr>
-              <a:t>Maicol Robles</a:t>
+              <a:t>Diego Robles</a:t>
             </a:r>
             <a:endParaRPr lang="en-US" sz="1300" dirty="0"/>
           </a:p>
           <a:p>
-            <a:pPr indent="0" marL="0">
+            <a:pPr marL="0" indent="0">
               <a:buNone/>
             </a:pPr>
             <a:r>
@@ -2193,7 +2032,7 @@
                 <a:ea typeface="Open Sans" pitchFamily="34" charset="-122"/>
                 <a:cs typeface="Open Sans" pitchFamily="34" charset="-120"/>
               </a:rPr>
-              <a:t>Codigo: 192125</a:t>
+              <a:t>Codigo: 191980</a:t>
             </a:r>
             <a:endParaRPr lang="en-US" sz="1300" dirty="0"/>
           </a:p>
@@ -2220,20 +2059,9 @@
           <a:bodyPr wrap="square" rtlCol="0" anchor="ctr"/>
           <a:lstStyle/>
           <a:p>
-            <a:pPr indent="0" marL="0">
-              <a:buNone/>
-            </a:pPr>
-            <a:r>
-              <a:rPr lang="en-US" sz="1100" b="1" dirty="0">
-                <a:solidFill>
-                  <a:srgbClr val="888888"/>
-                </a:solidFill>
-                <a:latin typeface="Open Sans" pitchFamily="34" charset="0"/>
-                <a:ea typeface="Open Sans" pitchFamily="34" charset="-122"/>
-                <a:cs typeface="Open Sans" pitchFamily="34" charset="-120"/>
-              </a:rPr>
-              <a:t>Docente:</a:t>
-            </a:r>
+            <a:pPr marL="0" indent="0">
+              <a:buNone/>
+            </a:pPr>
             <a:endParaRPr lang="en-US" sz="1100" dirty="0"/>
           </a:p>
         </p:txBody>
@@ -2259,20 +2087,9 @@
           <a:bodyPr wrap="square" rtlCol="0" anchor="ctr"/>
           <a:lstStyle/>
           <a:p>
-            <a:pPr indent="0" marL="0">
-              <a:buNone/>
-            </a:pPr>
-            <a:r>
-              <a:rPr lang="en-US" sz="1300" dirty="0">
-                <a:solidFill>
-                  <a:srgbClr val="000000"/>
-                </a:solidFill>
-                <a:latin typeface="Open Sans" pitchFamily="34" charset="0"/>
-                <a:ea typeface="Open Sans" pitchFamily="34" charset="-122"/>
-                <a:cs typeface="Open Sans" pitchFamily="34" charset="-120"/>
-              </a:rPr>
-              <a:t>Ing. ______________________</a:t>
-            </a:r>
+            <a:pPr marL="0" indent="0">
+              <a:buNone/>
+            </a:pPr>
             <a:endParaRPr lang="en-US" sz="1300" dirty="0"/>
           </a:p>
         </p:txBody>
@@ -2298,20 +2115,9 @@
           <a:bodyPr wrap="square" rtlCol="0" anchor="ctr"/>
           <a:lstStyle/>
           <a:p>
-            <a:pPr indent="0" marL="0">
-              <a:buNone/>
-            </a:pPr>
-            <a:r>
-              <a:rPr lang="en-US" sz="1100" dirty="0">
-                <a:solidFill>
-                  <a:srgbClr val="888888"/>
-                </a:solidFill>
-                <a:latin typeface="Open Sans" pitchFamily="34" charset="0"/>
-                <a:ea typeface="Open Sans" pitchFamily="34" charset="-122"/>
-                <a:cs typeface="Open Sans" pitchFamily="34" charset="-120"/>
-              </a:rPr>
-              <a:t>Ocana, 2026</a:t>
-            </a:r>
+            <a:pPr marL="0" indent="0">
+              <a:buNone/>
+            </a:pPr>
             <a:endParaRPr lang="en-US" sz="1100" dirty="0"/>
           </a:p>
         </p:txBody>
@@ -2365,6 +2171,13 @@
             <a:prstDash val="solid"/>
           </a:ln>
         </p:spPr>
+        <p:txBody>
+          <a:bodyPr/>
+          <a:lstStyle/>
+          <a:p>
+            <a:endParaRPr lang="es-CO"/>
+          </a:p>
+        </p:txBody>
       </p:sp>
       <p:sp>
         <p:nvSpPr>
@@ -2387,7 +2200,7 @@
           <a:bodyPr wrap="square" lIns="0" tIns="0" rIns="0" bIns="0" rtlCol="0" anchor="ctr"/>
           <a:lstStyle/>
           <a:p>
-            <a:pPr indent="0" marL="0">
+            <a:pPr marL="0" indent="0">
               <a:buNone/>
             </a:pPr>
             <a:r>
@@ -2429,6 +2242,13 @@
             <a:prstDash val="solid"/>
           </a:ln>
         </p:spPr>
+        <p:txBody>
+          <a:bodyPr/>
+          <a:lstStyle/>
+          <a:p>
+            <a:endParaRPr lang="es-CO"/>
+          </a:p>
+        </p:txBody>
       </p:sp>
       <p:sp>
         <p:nvSpPr>
@@ -2454,6 +2274,13 @@
             <a:prstDash val="solid"/>
           </a:ln>
         </p:spPr>
+        <p:txBody>
+          <a:bodyPr/>
+          <a:lstStyle/>
+          <a:p>
+            <a:endParaRPr lang="es-CO"/>
+          </a:p>
+        </p:txBody>
       </p:sp>
       <p:sp>
         <p:nvSpPr>
@@ -2476,7 +2303,7 @@
           <a:bodyPr wrap="square" rtlCol="0" anchor="ctr"/>
           <a:lstStyle/>
           <a:p>
-            <a:pPr indent="0" marL="0">
+            <a:pPr marL="0" indent="0">
               <a:buNone/>
             </a:pPr>
             <a:r>
@@ -2518,6 +2345,13 @@
             <a:prstDash val="solid"/>
           </a:ln>
         </p:spPr>
+        <p:txBody>
+          <a:bodyPr/>
+          <a:lstStyle/>
+          <a:p>
+            <a:endParaRPr lang="es-CO"/>
+          </a:p>
+        </p:txBody>
       </p:sp>
       <p:sp>
         <p:nvSpPr>
@@ -2543,6 +2377,13 @@
             <a:prstDash val="solid"/>
           </a:ln>
         </p:spPr>
+        <p:txBody>
+          <a:bodyPr/>
+          <a:lstStyle/>
+          <a:p>
+            <a:endParaRPr lang="es-CO"/>
+          </a:p>
+        </p:txBody>
       </p:sp>
       <p:sp>
         <p:nvSpPr>
@@ -2565,7 +2406,7 @@
           <a:bodyPr wrap="square" lIns="0" tIns="0" rIns="0" bIns="0" rtlCol="0" anchor="ctr"/>
           <a:lstStyle/>
           <a:p>
-            <a:pPr indent="0" marL="0">
+            <a:pPr marL="0" indent="0">
               <a:buNone/>
             </a:pPr>
             <a:r>
@@ -2604,7 +2445,7 @@
           <a:bodyPr wrap="square" lIns="0" tIns="0" rIns="0" bIns="0" rtlCol="0" anchor="t"/>
           <a:lstStyle/>
           <a:p>
-            <a:pPr indent="0" marL="0">
+            <a:pPr marL="0" indent="0">
               <a:buNone/>
             </a:pPr>
             <a:r>
@@ -2621,7 +2462,7 @@
             <a:endParaRPr lang="en-US" sz="950" dirty="0"/>
           </a:p>
           <a:p>
-            <a:pPr indent="0" marL="0">
+            <a:pPr marL="0" indent="0">
               <a:buNone/>
             </a:pPr>
             <a:r>
@@ -2638,7 +2479,7 @@
             <a:endParaRPr lang="en-US" sz="950" dirty="0"/>
           </a:p>
           <a:p>
-            <a:pPr indent="0" marL="0">
+            <a:pPr marL="0" indent="0">
               <a:buNone/>
             </a:pPr>
             <a:r>
@@ -2680,6 +2521,13 @@
             <a:prstDash val="solid"/>
           </a:ln>
         </p:spPr>
+        <p:txBody>
+          <a:bodyPr/>
+          <a:lstStyle/>
+          <a:p>
+            <a:endParaRPr lang="es-CO"/>
+          </a:p>
+        </p:txBody>
       </p:sp>
       <p:sp>
         <p:nvSpPr>
@@ -2702,7 +2550,7 @@
           <a:bodyPr wrap="square" lIns="0" tIns="0" rIns="0" bIns="0" rtlCol="0" anchor="ctr"/>
           <a:lstStyle/>
           <a:p>
-            <a:pPr algn="ctr" indent="0" marL="0">
+            <a:pPr marL="0" indent="0" algn="ctr">
               <a:buNone/>
             </a:pPr>
             <a:r>
@@ -2744,6 +2592,13 @@
             <a:prstDash val="solid"/>
           </a:ln>
         </p:spPr>
+        <p:txBody>
+          <a:bodyPr/>
+          <a:lstStyle/>
+          <a:p>
+            <a:endParaRPr lang="es-CO"/>
+          </a:p>
+        </p:txBody>
       </p:sp>
       <p:sp>
         <p:nvSpPr>
@@ -2769,6 +2624,13 @@
             <a:prstDash val="solid"/>
           </a:ln>
         </p:spPr>
+        <p:txBody>
+          <a:bodyPr/>
+          <a:lstStyle/>
+          <a:p>
+            <a:endParaRPr lang="es-CO"/>
+          </a:p>
+        </p:txBody>
       </p:sp>
       <p:sp>
         <p:nvSpPr>
@@ -2791,7 +2653,7 @@
           <a:bodyPr wrap="square" lIns="0" tIns="0" rIns="0" bIns="0" rtlCol="0" anchor="ctr"/>
           <a:lstStyle/>
           <a:p>
-            <a:pPr indent="0" marL="0">
+            <a:pPr marL="0" indent="0">
               <a:buNone/>
             </a:pPr>
             <a:r>
@@ -2830,7 +2692,7 @@
           <a:bodyPr wrap="square" lIns="0" tIns="0" rIns="0" bIns="0" rtlCol="0" anchor="t"/>
           <a:lstStyle/>
           <a:p>
-            <a:pPr indent="0" marL="0">
+            <a:pPr marL="0" indent="0">
               <a:buNone/>
             </a:pPr>
             <a:r>
@@ -2847,7 +2709,7 @@
             <a:endParaRPr lang="en-US" sz="950" dirty="0"/>
           </a:p>
           <a:p>
-            <a:pPr indent="0" marL="0">
+            <a:pPr marL="0" indent="0">
               <a:buNone/>
             </a:pPr>
             <a:r>
@@ -2864,7 +2726,7 @@
             <a:endParaRPr lang="en-US" sz="950" dirty="0"/>
           </a:p>
           <a:p>
-            <a:pPr indent="0" marL="0">
+            <a:pPr marL="0" indent="0">
               <a:buNone/>
             </a:pPr>
             <a:r>
@@ -2906,6 +2768,13 @@
             <a:prstDash val="solid"/>
           </a:ln>
         </p:spPr>
+        <p:txBody>
+          <a:bodyPr/>
+          <a:lstStyle/>
+          <a:p>
+            <a:endParaRPr lang="es-CO"/>
+          </a:p>
+        </p:txBody>
       </p:sp>
       <p:sp>
         <p:nvSpPr>
@@ -2928,7 +2797,7 @@
           <a:bodyPr wrap="square" lIns="0" tIns="0" rIns="0" bIns="0" rtlCol="0" anchor="ctr"/>
           <a:lstStyle/>
           <a:p>
-            <a:pPr algn="ctr" indent="0" marL="0">
+            <a:pPr marL="0" indent="0" algn="ctr">
               <a:buNone/>
             </a:pPr>
             <a:r>
@@ -2970,6 +2839,13 @@
             <a:prstDash val="solid"/>
           </a:ln>
         </p:spPr>
+        <p:txBody>
+          <a:bodyPr/>
+          <a:lstStyle/>
+          <a:p>
+            <a:endParaRPr lang="es-CO"/>
+          </a:p>
+        </p:txBody>
       </p:sp>
       <p:sp>
         <p:nvSpPr>
@@ -2995,6 +2871,13 @@
             <a:prstDash val="solid"/>
           </a:ln>
         </p:spPr>
+        <p:txBody>
+          <a:bodyPr/>
+          <a:lstStyle/>
+          <a:p>
+            <a:endParaRPr lang="es-CO"/>
+          </a:p>
+        </p:txBody>
       </p:sp>
       <p:sp>
         <p:nvSpPr>
@@ -3017,7 +2900,7 @@
           <a:bodyPr wrap="square" lIns="0" tIns="0" rIns="0" bIns="0" rtlCol="0" anchor="ctr"/>
           <a:lstStyle/>
           <a:p>
-            <a:pPr indent="0" marL="0">
+            <a:pPr marL="0" indent="0">
               <a:buNone/>
             </a:pPr>
             <a:r>
@@ -3056,7 +2939,7 @@
           <a:bodyPr wrap="square" lIns="0" tIns="0" rIns="0" bIns="0" rtlCol="0" anchor="t"/>
           <a:lstStyle/>
           <a:p>
-            <a:pPr indent="0" marL="0">
+            <a:pPr marL="0" indent="0">
               <a:buNone/>
             </a:pPr>
             <a:r>
@@ -3073,7 +2956,7 @@
             <a:endParaRPr lang="en-US" sz="950" dirty="0"/>
           </a:p>
           <a:p>
-            <a:pPr indent="0" marL="0">
+            <a:pPr marL="0" indent="0">
               <a:buNone/>
             </a:pPr>
             <a:r>
@@ -3090,7 +2973,7 @@
             <a:endParaRPr lang="en-US" sz="950" dirty="0"/>
           </a:p>
           <a:p>
-            <a:pPr indent="0" marL="0">
+            <a:pPr marL="0" indent="0">
               <a:buNone/>
             </a:pPr>
             <a:r>
@@ -3132,6 +3015,13 @@
             <a:prstDash val="solid"/>
           </a:ln>
         </p:spPr>
+        <p:txBody>
+          <a:bodyPr/>
+          <a:lstStyle/>
+          <a:p>
+            <a:endParaRPr lang="es-CO"/>
+          </a:p>
+        </p:txBody>
       </p:sp>
       <p:sp>
         <p:nvSpPr>
@@ -3154,7 +3044,7 @@
           <a:bodyPr wrap="square" lIns="0" tIns="0" rIns="0" bIns="0" rtlCol="0" anchor="ctr"/>
           <a:lstStyle/>
           <a:p>
-            <a:pPr algn="ctr" indent="0" marL="0">
+            <a:pPr marL="0" indent="0" algn="ctr">
               <a:buNone/>
             </a:pPr>
             <a:r>
@@ -3196,6 +3086,13 @@
             <a:prstDash val="solid"/>
           </a:ln>
         </p:spPr>
+        <p:txBody>
+          <a:bodyPr/>
+          <a:lstStyle/>
+          <a:p>
+            <a:endParaRPr lang="es-CO"/>
+          </a:p>
+        </p:txBody>
       </p:sp>
       <p:sp>
         <p:nvSpPr>
@@ -3221,6 +3118,13 @@
             <a:prstDash val="solid"/>
           </a:ln>
         </p:spPr>
+        <p:txBody>
+          <a:bodyPr/>
+          <a:lstStyle/>
+          <a:p>
+            <a:endParaRPr lang="es-CO"/>
+          </a:p>
+        </p:txBody>
       </p:sp>
       <p:sp>
         <p:nvSpPr>
@@ -3243,7 +3147,7 @@
           <a:bodyPr wrap="square" lIns="0" tIns="0" rIns="0" bIns="0" rtlCol="0" anchor="ctr"/>
           <a:lstStyle/>
           <a:p>
-            <a:pPr indent="0" marL="0">
+            <a:pPr marL="0" indent="0">
               <a:buNone/>
             </a:pPr>
             <a:r>
@@ -3282,7 +3186,7 @@
           <a:bodyPr wrap="square" lIns="0" tIns="0" rIns="0" bIns="0" rtlCol="0" anchor="t"/>
           <a:lstStyle/>
           <a:p>
-            <a:pPr indent="0" marL="0">
+            <a:pPr marL="0" indent="0">
               <a:buNone/>
             </a:pPr>
             <a:r>
@@ -3299,7 +3203,7 @@
             <a:endParaRPr lang="en-US" sz="950" dirty="0"/>
           </a:p>
           <a:p>
-            <a:pPr indent="0" marL="0">
+            <a:pPr marL="0" indent="0">
               <a:buNone/>
             </a:pPr>
             <a:r>
@@ -3316,7 +3220,7 @@
             <a:endParaRPr lang="en-US" sz="950" dirty="0"/>
           </a:p>
           <a:p>
-            <a:pPr indent="0" marL="0">
+            <a:pPr marL="0" indent="0">
               <a:buNone/>
             </a:pPr>
             <a:r>
@@ -3358,6 +3262,13 @@
             <a:prstDash val="solid"/>
           </a:ln>
         </p:spPr>
+        <p:txBody>
+          <a:bodyPr/>
+          <a:lstStyle/>
+          <a:p>
+            <a:endParaRPr lang="es-CO"/>
+          </a:p>
+        </p:txBody>
       </p:sp>
       <p:sp>
         <p:nvSpPr>
@@ -3380,7 +3291,7 @@
           <a:bodyPr wrap="square" lIns="0" tIns="0" rIns="0" bIns="0" rtlCol="0" anchor="ctr"/>
           <a:lstStyle/>
           <a:p>
-            <a:pPr algn="ctr" indent="0" marL="0">
+            <a:pPr marL="0" indent="0" algn="ctr">
               <a:buNone/>
             </a:pPr>
             <a:r>
@@ -3422,6 +3333,13 @@
             <a:prstDash val="solid"/>
           </a:ln>
         </p:spPr>
+        <p:txBody>
+          <a:bodyPr/>
+          <a:lstStyle/>
+          <a:p>
+            <a:endParaRPr lang="es-CO"/>
+          </a:p>
+        </p:txBody>
       </p:sp>
       <p:sp>
         <p:nvSpPr>
@@ -3447,6 +3365,13 @@
             <a:prstDash val="solid"/>
           </a:ln>
         </p:spPr>
+        <p:txBody>
+          <a:bodyPr/>
+          <a:lstStyle/>
+          <a:p>
+            <a:endParaRPr lang="es-CO"/>
+          </a:p>
+        </p:txBody>
       </p:sp>
       <p:sp>
         <p:nvSpPr>
@@ -3469,7 +3394,7 @@
           <a:bodyPr wrap="square" lIns="0" tIns="0" rIns="0" bIns="0" rtlCol="0" anchor="ctr"/>
           <a:lstStyle/>
           <a:p>
-            <a:pPr indent="0" marL="0">
+            <a:pPr marL="0" indent="0">
               <a:buNone/>
             </a:pPr>
             <a:r>
@@ -3508,7 +3433,7 @@
           <a:bodyPr wrap="square" lIns="0" tIns="0" rIns="0" bIns="0" rtlCol="0" anchor="t"/>
           <a:lstStyle/>
           <a:p>
-            <a:pPr indent="0" marL="0">
+            <a:pPr marL="0" indent="0">
               <a:buNone/>
             </a:pPr>
             <a:r>
@@ -3525,7 +3450,7 @@
             <a:endParaRPr lang="en-US" sz="950" dirty="0"/>
           </a:p>
           <a:p>
-            <a:pPr indent="0" marL="0">
+            <a:pPr marL="0" indent="0">
               <a:buNone/>
             </a:pPr>
             <a:r>
@@ -3542,7 +3467,7 @@
             <a:endParaRPr lang="en-US" sz="950" dirty="0"/>
           </a:p>
           <a:p>
-            <a:pPr indent="0" marL="0">
+            <a:pPr marL="0" indent="0">
               <a:buNone/>
             </a:pPr>
             <a:r>
@@ -3584,6 +3509,13 @@
             <a:prstDash val="solid"/>
           </a:ln>
         </p:spPr>
+        <p:txBody>
+          <a:bodyPr/>
+          <a:lstStyle/>
+          <a:p>
+            <a:endParaRPr lang="es-CO"/>
+          </a:p>
+        </p:txBody>
       </p:sp>
       <p:sp>
         <p:nvSpPr>
@@ -3606,7 +3538,7 @@
           <a:bodyPr wrap="square" lIns="0" tIns="0" rIns="0" bIns="0" rtlCol="0" anchor="ctr"/>
           <a:lstStyle/>
           <a:p>
-            <a:pPr algn="ctr" indent="0" marL="0">
+            <a:pPr marL="0" indent="0" algn="ctr">
               <a:buNone/>
             </a:pPr>
             <a:r>
@@ -3673,6 +3605,13 @@
             <a:prstDash val="solid"/>
           </a:ln>
         </p:spPr>
+        <p:txBody>
+          <a:bodyPr/>
+          <a:lstStyle/>
+          <a:p>
+            <a:endParaRPr lang="es-CO"/>
+          </a:p>
+        </p:txBody>
       </p:sp>
       <p:sp>
         <p:nvSpPr>
@@ -3695,7 +3634,7 @@
           <a:bodyPr wrap="square" lIns="0" tIns="0" rIns="0" bIns="0" rtlCol="0" anchor="ctr"/>
           <a:lstStyle/>
           <a:p>
-            <a:pPr indent="0" marL="0">
+            <a:pPr marL="0" indent="0">
               <a:buNone/>
             </a:pPr>
             <a:r>
@@ -3737,6 +3676,13 @@
             <a:prstDash val="solid"/>
           </a:ln>
         </p:spPr>
+        <p:txBody>
+          <a:bodyPr/>
+          <a:lstStyle/>
+          <a:p>
+            <a:endParaRPr lang="es-CO"/>
+          </a:p>
+        </p:txBody>
       </p:sp>
       <p:sp>
         <p:nvSpPr>
@@ -3762,6 +3708,13 @@
             <a:prstDash val="solid"/>
           </a:ln>
         </p:spPr>
+        <p:txBody>
+          <a:bodyPr/>
+          <a:lstStyle/>
+          <a:p>
+            <a:endParaRPr lang="es-CO"/>
+          </a:p>
+        </p:txBody>
       </p:sp>
       <p:sp>
         <p:nvSpPr>
@@ -3784,7 +3737,7 @@
           <a:bodyPr wrap="square" rtlCol="0" anchor="ctr"/>
           <a:lstStyle/>
           <a:p>
-            <a:pPr indent="0" marL="0">
+            <a:pPr marL="0" indent="0">
               <a:buNone/>
             </a:pPr>
             <a:r>
@@ -3826,6 +3779,13 @@
             <a:prstDash val="solid"/>
           </a:ln>
         </p:spPr>
+        <p:txBody>
+          <a:bodyPr/>
+          <a:lstStyle/>
+          <a:p>
+            <a:endParaRPr lang="es-CO"/>
+          </a:p>
+        </p:txBody>
       </p:sp>
       <p:sp>
         <p:nvSpPr>
@@ -3848,7 +3808,7 @@
           <a:bodyPr wrap="square" lIns="0" tIns="0" rIns="0" bIns="0" rtlCol="0" anchor="ctr"/>
           <a:lstStyle/>
           <a:p>
-            <a:pPr algn="ctr" indent="0" marL="0">
+            <a:pPr marL="0" indent="0" algn="ctr">
               <a:buNone/>
             </a:pPr>
             <a:r>
@@ -3890,6 +3850,13 @@
             <a:prstDash val="solid"/>
           </a:ln>
         </p:spPr>
+        <p:txBody>
+          <a:bodyPr/>
+          <a:lstStyle/>
+          <a:p>
+            <a:endParaRPr lang="es-CO"/>
+          </a:p>
+        </p:txBody>
       </p:sp>
       <p:sp>
         <p:nvSpPr>
@@ -3912,7 +3879,7 @@
           <a:bodyPr wrap="square" lIns="0" tIns="0" rIns="0" bIns="0" rtlCol="0" anchor="ctr"/>
           <a:lstStyle/>
           <a:p>
-            <a:pPr indent="0" marL="0">
+            <a:pPr marL="0" indent="0">
               <a:buNone/>
             </a:pPr>
             <a:r>
@@ -3954,6 +3921,13 @@
             <a:prstDash val="solid"/>
           </a:ln>
         </p:spPr>
+        <p:txBody>
+          <a:bodyPr/>
+          <a:lstStyle/>
+          <a:p>
+            <a:endParaRPr lang="es-CO"/>
+          </a:p>
+        </p:txBody>
       </p:sp>
       <p:sp>
         <p:nvSpPr>
@@ -3976,7 +3950,7 @@
           <a:bodyPr wrap="square" lIns="0" tIns="0" rIns="0" bIns="0" rtlCol="0" anchor="ctr"/>
           <a:lstStyle/>
           <a:p>
-            <a:pPr algn="ctr" indent="0" marL="0">
+            <a:pPr marL="0" indent="0" algn="ctr">
               <a:buNone/>
             </a:pPr>
             <a:r>
@@ -4018,6 +3992,13 @@
             <a:prstDash val="solid"/>
           </a:ln>
         </p:spPr>
+        <p:txBody>
+          <a:bodyPr/>
+          <a:lstStyle/>
+          <a:p>
+            <a:endParaRPr lang="es-CO"/>
+          </a:p>
+        </p:txBody>
       </p:sp>
       <p:sp>
         <p:nvSpPr>
@@ -4040,7 +4021,7 @@
           <a:bodyPr wrap="square" lIns="0" tIns="0" rIns="0" bIns="0" rtlCol="0" anchor="ctr"/>
           <a:lstStyle/>
           <a:p>
-            <a:pPr indent="0" marL="0">
+            <a:pPr marL="0" indent="0">
               <a:buNone/>
             </a:pPr>
             <a:r>
@@ -4082,6 +4063,13 @@
             <a:prstDash val="solid"/>
           </a:ln>
         </p:spPr>
+        <p:txBody>
+          <a:bodyPr/>
+          <a:lstStyle/>
+          <a:p>
+            <a:endParaRPr lang="es-CO"/>
+          </a:p>
+        </p:txBody>
       </p:sp>
       <p:sp>
         <p:nvSpPr>
@@ -4104,7 +4092,7 @@
           <a:bodyPr wrap="square" lIns="0" tIns="0" rIns="0" bIns="0" rtlCol="0" anchor="ctr"/>
           <a:lstStyle/>
           <a:p>
-            <a:pPr algn="ctr" indent="0" marL="0">
+            <a:pPr marL="0" indent="0" algn="ctr">
               <a:buNone/>
             </a:pPr>
             <a:r>
@@ -4146,6 +4134,13 @@
             <a:prstDash val="solid"/>
           </a:ln>
         </p:spPr>
+        <p:txBody>
+          <a:bodyPr/>
+          <a:lstStyle/>
+          <a:p>
+            <a:endParaRPr lang="es-CO"/>
+          </a:p>
+        </p:txBody>
       </p:sp>
       <p:sp>
         <p:nvSpPr>
@@ -4168,7 +4163,7 @@
           <a:bodyPr wrap="square" lIns="0" tIns="0" rIns="0" bIns="0" rtlCol="0" anchor="ctr"/>
           <a:lstStyle/>
           <a:p>
-            <a:pPr indent="0" marL="0">
+            <a:pPr marL="0" indent="0">
               <a:buNone/>
             </a:pPr>
             <a:r>
@@ -4210,6 +4205,13 @@
             <a:prstDash val="solid"/>
           </a:ln>
         </p:spPr>
+        <p:txBody>
+          <a:bodyPr/>
+          <a:lstStyle/>
+          <a:p>
+            <a:endParaRPr lang="es-CO"/>
+          </a:p>
+        </p:txBody>
       </p:sp>
       <p:sp>
         <p:nvSpPr>
@@ -4232,7 +4234,7 @@
           <a:bodyPr wrap="square" lIns="0" tIns="0" rIns="0" bIns="0" rtlCol="0" anchor="ctr"/>
           <a:lstStyle/>
           <a:p>
-            <a:pPr algn="ctr" indent="0" marL="0">
+            <a:pPr marL="0" indent="0" algn="ctr">
               <a:buNone/>
             </a:pPr>
             <a:r>
@@ -4274,6 +4276,13 @@
             <a:prstDash val="solid"/>
           </a:ln>
         </p:spPr>
+        <p:txBody>
+          <a:bodyPr/>
+          <a:lstStyle/>
+          <a:p>
+            <a:endParaRPr lang="es-CO"/>
+          </a:p>
+        </p:txBody>
       </p:sp>
       <p:sp>
         <p:nvSpPr>
@@ -4296,7 +4305,7 @@
           <a:bodyPr wrap="square" lIns="0" tIns="0" rIns="0" bIns="0" rtlCol="0" anchor="ctr"/>
           <a:lstStyle/>
           <a:p>
-            <a:pPr indent="0" marL="0">
+            <a:pPr marL="0" indent="0">
               <a:buNone/>
             </a:pPr>
             <a:r>
@@ -4338,6 +4347,13 @@
             <a:prstDash val="solid"/>
           </a:ln>
         </p:spPr>
+        <p:txBody>
+          <a:bodyPr/>
+          <a:lstStyle/>
+          <a:p>
+            <a:endParaRPr lang="es-CO"/>
+          </a:p>
+        </p:txBody>
       </p:sp>
       <p:sp>
         <p:nvSpPr>
@@ -4360,7 +4376,7 @@
           <a:bodyPr wrap="square" lIns="0" tIns="0" rIns="0" bIns="0" rtlCol="0" anchor="ctr"/>
           <a:lstStyle/>
           <a:p>
-            <a:pPr algn="ctr" indent="0" marL="0">
+            <a:pPr marL="0" indent="0" algn="ctr">
               <a:buNone/>
             </a:pPr>
             <a:r>
@@ -4402,6 +4418,13 @@
             <a:prstDash val="solid"/>
           </a:ln>
         </p:spPr>
+        <p:txBody>
+          <a:bodyPr/>
+          <a:lstStyle/>
+          <a:p>
+            <a:endParaRPr lang="es-CO"/>
+          </a:p>
+        </p:txBody>
       </p:sp>
       <p:sp>
         <p:nvSpPr>
@@ -4424,7 +4447,7 @@
           <a:bodyPr wrap="square" lIns="0" tIns="0" rIns="0" bIns="0" rtlCol="0" anchor="ctr"/>
           <a:lstStyle/>
           <a:p>
-            <a:pPr indent="0" marL="0">
+            <a:pPr marL="0" indent="0">
               <a:buNone/>
             </a:pPr>
             <a:r>
@@ -4491,6 +4514,13 @@
             <a:prstDash val="solid"/>
           </a:ln>
         </p:spPr>
+        <p:txBody>
+          <a:bodyPr/>
+          <a:lstStyle/>
+          <a:p>
+            <a:endParaRPr lang="es-CO"/>
+          </a:p>
+        </p:txBody>
       </p:sp>
       <p:sp>
         <p:nvSpPr>
@@ -4513,7 +4543,7 @@
           <a:bodyPr wrap="square" lIns="0" tIns="0" rIns="0" bIns="0" rtlCol="0" anchor="ctr"/>
           <a:lstStyle/>
           <a:p>
-            <a:pPr indent="0" marL="0">
+            <a:pPr marL="0" indent="0">
               <a:buNone/>
             </a:pPr>
             <a:r>
@@ -4555,6 +4585,13 @@
             <a:prstDash val="solid"/>
           </a:ln>
         </p:spPr>
+        <p:txBody>
+          <a:bodyPr/>
+          <a:lstStyle/>
+          <a:p>
+            <a:endParaRPr lang="es-CO"/>
+          </a:p>
+        </p:txBody>
       </p:sp>
       <p:sp>
         <p:nvSpPr>
@@ -4580,6 +4617,13 @@
             <a:prstDash val="solid"/>
           </a:ln>
         </p:spPr>
+        <p:txBody>
+          <a:bodyPr/>
+          <a:lstStyle/>
+          <a:p>
+            <a:endParaRPr lang="es-CO"/>
+          </a:p>
+        </p:txBody>
       </p:sp>
       <p:sp>
         <p:nvSpPr>
@@ -4602,7 +4646,7 @@
           <a:bodyPr wrap="square" rtlCol="0" anchor="ctr"/>
           <a:lstStyle/>
           <a:p>
-            <a:pPr indent="0" marL="0">
+            <a:pPr marL="0" indent="0">
               <a:buNone/>
             </a:pPr>
             <a:r>
@@ -4641,7 +4685,7 @@
           <a:bodyPr wrap="square" rtlCol="0" anchor="ctr"/>
           <a:lstStyle/>
           <a:p>
-            <a:pPr indent="0" marL="0">
+            <a:pPr marL="0" indent="0">
               <a:buNone/>
             </a:pPr>
             <a:r>
@@ -4683,6 +4727,13 @@
             <a:prstDash val="solid"/>
           </a:ln>
         </p:spPr>
+        <p:txBody>
+          <a:bodyPr/>
+          <a:lstStyle/>
+          <a:p>
+            <a:endParaRPr lang="es-CO"/>
+          </a:p>
+        </p:txBody>
       </p:sp>
       <p:sp>
         <p:nvSpPr>
@@ -4705,7 +4756,7 @@
           <a:bodyPr wrap="square" rtlCol="0" anchor="ctr"/>
           <a:lstStyle/>
           <a:p>
-            <a:pPr algn="ctr" indent="0" marL="0">
+            <a:pPr marL="0" indent="0" algn="ctr">
               <a:buNone/>
             </a:pPr>
             <a:r>
@@ -4744,7 +4795,7 @@
           <a:bodyPr wrap="square" rtlCol="0" anchor="ctr"/>
           <a:lstStyle/>
           <a:p>
-            <a:pPr indent="0" marL="0">
+            <a:pPr marL="0" indent="0">
               <a:buNone/>
             </a:pPr>
             <a:r>
@@ -4783,7 +4834,7 @@
           <a:bodyPr wrap="square" rtlCol="0" anchor="t"/>
           <a:lstStyle/>
           <a:p>
-            <a:pPr indent="0" marL="0">
+            <a:pPr marL="0" indent="0">
               <a:buNone/>
             </a:pPr>
             <a:r>
@@ -4825,6 +4876,13 @@
             <a:prstDash val="solid"/>
           </a:ln>
         </p:spPr>
+        <p:txBody>
+          <a:bodyPr/>
+          <a:lstStyle/>
+          <a:p>
+            <a:endParaRPr lang="es-CO"/>
+          </a:p>
+        </p:txBody>
       </p:sp>
       <p:sp>
         <p:nvSpPr>
@@ -4847,7 +4905,7 @@
           <a:bodyPr wrap="square" rtlCol="0" anchor="ctr"/>
           <a:lstStyle/>
           <a:p>
-            <a:pPr algn="ctr" indent="0" marL="0">
+            <a:pPr marL="0" indent="0" algn="ctr">
               <a:buNone/>
             </a:pPr>
             <a:r>
@@ -4886,7 +4944,7 @@
           <a:bodyPr wrap="square" rtlCol="0" anchor="ctr"/>
           <a:lstStyle/>
           <a:p>
-            <a:pPr indent="0" marL="0">
+            <a:pPr marL="0" indent="0">
               <a:buNone/>
             </a:pPr>
             <a:r>
@@ -4925,7 +4983,7 @@
           <a:bodyPr wrap="square" rtlCol="0" anchor="t"/>
           <a:lstStyle/>
           <a:p>
-            <a:pPr indent="0" marL="0">
+            <a:pPr marL="0" indent="0">
               <a:buNone/>
             </a:pPr>
             <a:r>
@@ -4967,6 +5025,13 @@
             <a:prstDash val="solid"/>
           </a:ln>
         </p:spPr>
+        <p:txBody>
+          <a:bodyPr/>
+          <a:lstStyle/>
+          <a:p>
+            <a:endParaRPr lang="es-CO"/>
+          </a:p>
+        </p:txBody>
       </p:sp>
       <p:sp>
         <p:nvSpPr>
@@ -4989,7 +5054,7 @@
           <a:bodyPr wrap="square" rtlCol="0" anchor="ctr"/>
           <a:lstStyle/>
           <a:p>
-            <a:pPr algn="ctr" indent="0" marL="0">
+            <a:pPr marL="0" indent="0" algn="ctr">
               <a:buNone/>
             </a:pPr>
             <a:r>
@@ -5028,7 +5093,7 @@
           <a:bodyPr wrap="square" rtlCol="0" anchor="ctr"/>
           <a:lstStyle/>
           <a:p>
-            <a:pPr indent="0" marL="0">
+            <a:pPr marL="0" indent="0">
               <a:buNone/>
             </a:pPr>
             <a:r>
@@ -5067,7 +5132,7 @@
           <a:bodyPr wrap="square" rtlCol="0" anchor="t"/>
           <a:lstStyle/>
           <a:p>
-            <a:pPr indent="0" marL="0">
+            <a:pPr marL="0" indent="0">
               <a:buNone/>
             </a:pPr>
             <a:r>
@@ -5134,6 +5199,13 @@
             <a:prstDash val="solid"/>
           </a:ln>
         </p:spPr>
+        <p:txBody>
+          <a:bodyPr/>
+          <a:lstStyle/>
+          <a:p>
+            <a:endParaRPr lang="es-CO"/>
+          </a:p>
+        </p:txBody>
       </p:sp>
       <p:sp>
         <p:nvSpPr>
@@ -5156,7 +5228,7 @@
           <a:bodyPr wrap="square" lIns="0" tIns="0" rIns="0" bIns="0" rtlCol="0" anchor="ctr"/>
           <a:lstStyle/>
           <a:p>
-            <a:pPr indent="0" marL="0">
+            <a:pPr marL="0" indent="0">
               <a:buNone/>
             </a:pPr>
             <a:r>
@@ -5198,6 +5270,13 @@
             <a:prstDash val="solid"/>
           </a:ln>
         </p:spPr>
+        <p:txBody>
+          <a:bodyPr/>
+          <a:lstStyle/>
+          <a:p>
+            <a:endParaRPr lang="es-CO"/>
+          </a:p>
+        </p:txBody>
       </p:sp>
       <p:sp>
         <p:nvSpPr>
@@ -5223,6 +5302,13 @@
             <a:prstDash val="solid"/>
           </a:ln>
         </p:spPr>
+        <p:txBody>
+          <a:bodyPr/>
+          <a:lstStyle/>
+          <a:p>
+            <a:endParaRPr lang="es-CO"/>
+          </a:p>
+        </p:txBody>
       </p:sp>
       <p:sp>
         <p:nvSpPr>
@@ -5245,7 +5331,7 @@
           <a:bodyPr wrap="square" rtlCol="0" anchor="ctr"/>
           <a:lstStyle/>
           <a:p>
-            <a:pPr indent="0" marL="0">
+            <a:pPr marL="0" indent="0">
               <a:buNone/>
             </a:pPr>
             <a:r>
@@ -5287,6 +5373,13 @@
             <a:prstDash val="solid"/>
           </a:ln>
         </p:spPr>
+        <p:txBody>
+          <a:bodyPr/>
+          <a:lstStyle/>
+          <a:p>
+            <a:endParaRPr lang="es-CO"/>
+          </a:p>
+        </p:txBody>
       </p:sp>
       <p:sp>
         <p:nvSpPr>
@@ -5312,6 +5405,13 @@
             <a:prstDash val="solid"/>
           </a:ln>
         </p:spPr>
+        <p:txBody>
+          <a:bodyPr/>
+          <a:lstStyle/>
+          <a:p>
+            <a:endParaRPr lang="es-CO"/>
+          </a:p>
+        </p:txBody>
       </p:sp>
       <p:sp>
         <p:nvSpPr>
@@ -5334,7 +5434,7 @@
           <a:bodyPr wrap="square" lIns="0" tIns="0" rIns="0" bIns="0" rtlCol="0" anchor="ctr"/>
           <a:lstStyle/>
           <a:p>
-            <a:pPr indent="0" marL="0">
+            <a:pPr marL="0" indent="0">
               <a:buNone/>
             </a:pPr>
             <a:r>
@@ -5373,7 +5473,7 @@
           <a:bodyPr wrap="square" lIns="0" tIns="0" rIns="0" bIns="0" rtlCol="0" anchor="ctr"/>
           <a:lstStyle/>
           <a:p>
-            <a:pPr indent="0" marL="0">
+            <a:pPr marL="0" indent="0">
               <a:buNone/>
             </a:pPr>
             <a:r>
@@ -5412,7 +5512,7 @@
           <a:bodyPr wrap="square" lIns="0" tIns="0" rIns="0" bIns="0" rtlCol="0" anchor="ctr"/>
           <a:lstStyle/>
           <a:p>
-            <a:pPr indent="0" marL="0">
+            <a:pPr marL="0" indent="0">
               <a:buNone/>
             </a:pPr>
             <a:r>
@@ -5454,6 +5554,13 @@
             <a:prstDash val="solid"/>
           </a:ln>
         </p:spPr>
+        <p:txBody>
+          <a:bodyPr/>
+          <a:lstStyle/>
+          <a:p>
+            <a:endParaRPr lang="es-CO"/>
+          </a:p>
+        </p:txBody>
       </p:sp>
       <p:sp>
         <p:nvSpPr>
@@ -5479,6 +5586,13 @@
             <a:prstDash val="solid"/>
           </a:ln>
         </p:spPr>
+        <p:txBody>
+          <a:bodyPr/>
+          <a:lstStyle/>
+          <a:p>
+            <a:endParaRPr lang="es-CO"/>
+          </a:p>
+        </p:txBody>
       </p:sp>
       <p:sp>
         <p:nvSpPr>
@@ -5501,7 +5615,7 @@
           <a:bodyPr wrap="square" lIns="0" tIns="0" rIns="0" bIns="0" rtlCol="0" anchor="ctr"/>
           <a:lstStyle/>
           <a:p>
-            <a:pPr indent="0" marL="0">
+            <a:pPr marL="0" indent="0">
               <a:buNone/>
             </a:pPr>
             <a:r>
@@ -5540,7 +5654,7 @@
           <a:bodyPr wrap="square" lIns="0" tIns="0" rIns="0" bIns="0" rtlCol="0" anchor="ctr"/>
           <a:lstStyle/>
           <a:p>
-            <a:pPr indent="0" marL="0">
+            <a:pPr marL="0" indent="0">
               <a:buNone/>
             </a:pPr>
             <a:r>
@@ -5579,7 +5693,7 @@
           <a:bodyPr wrap="square" lIns="0" tIns="0" rIns="0" bIns="0" rtlCol="0" anchor="ctr"/>
           <a:lstStyle/>
           <a:p>
-            <a:pPr indent="0" marL="0">
+            <a:pPr marL="0" indent="0">
               <a:buNone/>
             </a:pPr>
             <a:r>
@@ -5621,6 +5735,13 @@
             <a:prstDash val="solid"/>
           </a:ln>
         </p:spPr>
+        <p:txBody>
+          <a:bodyPr/>
+          <a:lstStyle/>
+          <a:p>
+            <a:endParaRPr lang="es-CO"/>
+          </a:p>
+        </p:txBody>
       </p:sp>
       <p:sp>
         <p:nvSpPr>
@@ -5646,6 +5767,13 @@
             <a:prstDash val="solid"/>
           </a:ln>
         </p:spPr>
+        <p:txBody>
+          <a:bodyPr/>
+          <a:lstStyle/>
+          <a:p>
+            <a:endParaRPr lang="es-CO"/>
+          </a:p>
+        </p:txBody>
       </p:sp>
       <p:sp>
         <p:nvSpPr>
@@ -5668,7 +5796,7 @@
           <a:bodyPr wrap="square" lIns="0" tIns="0" rIns="0" bIns="0" rtlCol="0" anchor="ctr"/>
           <a:lstStyle/>
           <a:p>
-            <a:pPr indent="0" marL="0">
+            <a:pPr marL="0" indent="0">
               <a:buNone/>
             </a:pPr>
             <a:r>
@@ -5707,7 +5835,7 @@
           <a:bodyPr wrap="square" lIns="0" tIns="0" rIns="0" bIns="0" rtlCol="0" anchor="ctr"/>
           <a:lstStyle/>
           <a:p>
-            <a:pPr indent="0" marL="0">
+            <a:pPr marL="0" indent="0">
               <a:buNone/>
             </a:pPr>
             <a:r>
@@ -5746,7 +5874,7 @@
           <a:bodyPr wrap="square" lIns="0" tIns="0" rIns="0" bIns="0" rtlCol="0" anchor="ctr"/>
           <a:lstStyle/>
           <a:p>
-            <a:pPr indent="0" marL="0">
+            <a:pPr marL="0" indent="0">
               <a:buNone/>
             </a:pPr>
             <a:r>
@@ -5813,6 +5941,13 @@
             <a:prstDash val="solid"/>
           </a:ln>
         </p:spPr>
+        <p:txBody>
+          <a:bodyPr/>
+          <a:lstStyle/>
+          <a:p>
+            <a:endParaRPr lang="es-CO"/>
+          </a:p>
+        </p:txBody>
       </p:sp>
       <p:sp>
         <p:nvSpPr>
@@ -5835,7 +5970,7 @@
           <a:bodyPr wrap="square" lIns="0" tIns="0" rIns="0" bIns="0" rtlCol="0" anchor="ctr"/>
           <a:lstStyle/>
           <a:p>
-            <a:pPr indent="0" marL="0">
+            <a:pPr marL="0" indent="0">
               <a:buNone/>
             </a:pPr>
             <a:r>
@@ -5877,6 +6012,13 @@
             <a:prstDash val="solid"/>
           </a:ln>
         </p:spPr>
+        <p:txBody>
+          <a:bodyPr/>
+          <a:lstStyle/>
+          <a:p>
+            <a:endParaRPr lang="es-CO"/>
+          </a:p>
+        </p:txBody>
       </p:sp>
       <p:sp>
         <p:nvSpPr>
@@ -5902,6 +6044,13 @@
             <a:prstDash val="solid"/>
           </a:ln>
         </p:spPr>
+        <p:txBody>
+          <a:bodyPr/>
+          <a:lstStyle/>
+          <a:p>
+            <a:endParaRPr lang="es-CO"/>
+          </a:p>
+        </p:txBody>
       </p:sp>
       <p:sp>
         <p:nvSpPr>
@@ -5924,7 +6073,7 @@
           <a:bodyPr wrap="square" rtlCol="0" anchor="ctr"/>
           <a:lstStyle/>
           <a:p>
-            <a:pPr indent="0" marL="0">
+            <a:pPr marL="0" indent="0">
               <a:buNone/>
             </a:pPr>
             <a:r>
@@ -5966,6 +6115,13 @@
             <a:prstDash val="solid"/>
           </a:ln>
         </p:spPr>
+        <p:txBody>
+          <a:bodyPr/>
+          <a:lstStyle/>
+          <a:p>
+            <a:endParaRPr lang="es-CO"/>
+          </a:p>
+        </p:txBody>
       </p:sp>
       <p:sp>
         <p:nvSpPr>
@@ -5988,7 +6144,7 @@
           <a:bodyPr wrap="square" lIns="0" tIns="0" rIns="0" bIns="0" rtlCol="0" anchor="ctr"/>
           <a:lstStyle/>
           <a:p>
-            <a:pPr algn="ctr" indent="0" marL="0">
+            <a:pPr marL="0" indent="0" algn="ctr">
               <a:buNone/>
             </a:pPr>
             <a:r>
@@ -6030,6 +6186,13 @@
             <a:prstDash val="solid"/>
           </a:ln>
         </p:spPr>
+        <p:txBody>
+          <a:bodyPr/>
+          <a:lstStyle/>
+          <a:p>
+            <a:endParaRPr lang="es-CO"/>
+          </a:p>
+        </p:txBody>
       </p:sp>
       <p:sp>
         <p:nvSpPr>
@@ -6052,7 +6215,7 @@
           <a:bodyPr wrap="square" lIns="0" tIns="0" rIns="0" bIns="0" rtlCol="0" anchor="ctr"/>
           <a:lstStyle/>
           <a:p>
-            <a:pPr indent="0" marL="0">
+            <a:pPr marL="0" indent="0">
               <a:buNone/>
             </a:pPr>
             <a:r>
@@ -6091,7 +6254,7 @@
           <a:bodyPr wrap="square" lIns="0" tIns="0" rIns="0" bIns="0" rtlCol="0" anchor="t"/>
           <a:lstStyle/>
           <a:p>
-            <a:pPr indent="0" marL="0">
+            <a:pPr marL="0" indent="0">
               <a:buNone/>
             </a:pPr>
             <a:r>
@@ -6133,6 +6296,13 @@
             <a:prstDash val="solid"/>
           </a:ln>
         </p:spPr>
+        <p:txBody>
+          <a:bodyPr/>
+          <a:lstStyle/>
+          <a:p>
+            <a:endParaRPr lang="es-CO"/>
+          </a:p>
+        </p:txBody>
       </p:sp>
       <p:sp>
         <p:nvSpPr>
@@ -6155,7 +6325,7 @@
           <a:bodyPr wrap="square" lIns="0" tIns="0" rIns="0" bIns="0" rtlCol="0" anchor="ctr"/>
           <a:lstStyle/>
           <a:p>
-            <a:pPr algn="ctr" indent="0" marL="0">
+            <a:pPr marL="0" indent="0" algn="ctr">
               <a:buNone/>
             </a:pPr>
             <a:r>
@@ -6197,6 +6367,13 @@
             <a:prstDash val="solid"/>
           </a:ln>
         </p:spPr>
+        <p:txBody>
+          <a:bodyPr/>
+          <a:lstStyle/>
+          <a:p>
+            <a:endParaRPr lang="es-CO"/>
+          </a:p>
+        </p:txBody>
       </p:sp>
       <p:sp>
         <p:nvSpPr>
@@ -6219,7 +6396,7 @@
           <a:bodyPr wrap="square" lIns="0" tIns="0" rIns="0" bIns="0" rtlCol="0" anchor="ctr"/>
           <a:lstStyle/>
           <a:p>
-            <a:pPr indent="0" marL="0">
+            <a:pPr marL="0" indent="0">
               <a:buNone/>
             </a:pPr>
             <a:r>
@@ -6258,7 +6435,7 @@
           <a:bodyPr wrap="square" lIns="0" tIns="0" rIns="0" bIns="0" rtlCol="0" anchor="t"/>
           <a:lstStyle/>
           <a:p>
-            <a:pPr indent="0" marL="0">
+            <a:pPr marL="0" indent="0">
               <a:buNone/>
             </a:pPr>
             <a:r>
@@ -6300,6 +6477,13 @@
             <a:prstDash val="solid"/>
           </a:ln>
         </p:spPr>
+        <p:txBody>
+          <a:bodyPr/>
+          <a:lstStyle/>
+          <a:p>
+            <a:endParaRPr lang="es-CO"/>
+          </a:p>
+        </p:txBody>
       </p:sp>
       <p:sp>
         <p:nvSpPr>
@@ -6322,7 +6506,7 @@
           <a:bodyPr wrap="square" lIns="0" tIns="0" rIns="0" bIns="0" rtlCol="0" anchor="ctr"/>
           <a:lstStyle/>
           <a:p>
-            <a:pPr algn="ctr" indent="0" marL="0">
+            <a:pPr marL="0" indent="0" algn="ctr">
               <a:buNone/>
             </a:pPr>
             <a:r>
@@ -6364,6 +6548,13 @@
             <a:prstDash val="solid"/>
           </a:ln>
         </p:spPr>
+        <p:txBody>
+          <a:bodyPr/>
+          <a:lstStyle/>
+          <a:p>
+            <a:endParaRPr lang="es-CO"/>
+          </a:p>
+        </p:txBody>
       </p:sp>
       <p:sp>
         <p:nvSpPr>
@@ -6386,7 +6577,7 @@
           <a:bodyPr wrap="square" lIns="0" tIns="0" rIns="0" bIns="0" rtlCol="0" anchor="ctr"/>
           <a:lstStyle/>
           <a:p>
-            <a:pPr indent="0" marL="0">
+            <a:pPr marL="0" indent="0">
               <a:buNone/>
             </a:pPr>
             <a:r>
@@ -6425,7 +6616,7 @@
           <a:bodyPr wrap="square" lIns="0" tIns="0" rIns="0" bIns="0" rtlCol="0" anchor="t"/>
           <a:lstStyle/>
           <a:p>
-            <a:pPr indent="0" marL="0">
+            <a:pPr marL="0" indent="0">
               <a:buNone/>
             </a:pPr>
             <a:r>
@@ -6467,6 +6658,13 @@
             <a:prstDash val="solid"/>
           </a:ln>
         </p:spPr>
+        <p:txBody>
+          <a:bodyPr/>
+          <a:lstStyle/>
+          <a:p>
+            <a:endParaRPr lang="es-CO"/>
+          </a:p>
+        </p:txBody>
       </p:sp>
       <p:sp>
         <p:nvSpPr>
@@ -6489,7 +6687,7 @@
           <a:bodyPr wrap="square" lIns="0" tIns="0" rIns="0" bIns="0" rtlCol="0" anchor="ctr"/>
           <a:lstStyle/>
           <a:p>
-            <a:pPr algn="ctr" indent="0" marL="0">
+            <a:pPr marL="0" indent="0" algn="ctr">
               <a:buNone/>
             </a:pPr>
             <a:r>
@@ -6531,6 +6729,13 @@
             <a:prstDash val="solid"/>
           </a:ln>
         </p:spPr>
+        <p:txBody>
+          <a:bodyPr/>
+          <a:lstStyle/>
+          <a:p>
+            <a:endParaRPr lang="es-CO"/>
+          </a:p>
+        </p:txBody>
       </p:sp>
       <p:sp>
         <p:nvSpPr>
@@ -6553,7 +6758,7 @@
           <a:bodyPr wrap="square" lIns="0" tIns="0" rIns="0" bIns="0" rtlCol="0" anchor="ctr"/>
           <a:lstStyle/>
           <a:p>
-            <a:pPr indent="0" marL="0">
+            <a:pPr marL="0" indent="0">
               <a:buNone/>
             </a:pPr>
             <a:r>
@@ -6592,7 +6797,7 @@
           <a:bodyPr wrap="square" lIns="0" tIns="0" rIns="0" bIns="0" rtlCol="0" anchor="t"/>
           <a:lstStyle/>
           <a:p>
-            <a:pPr indent="0" marL="0">
+            <a:pPr marL="0" indent="0">
               <a:buNone/>
             </a:pPr>
             <a:r>
@@ -6659,6 +6864,13 @@
             <a:prstDash val="solid"/>
           </a:ln>
         </p:spPr>
+        <p:txBody>
+          <a:bodyPr/>
+          <a:lstStyle/>
+          <a:p>
+            <a:endParaRPr lang="es-CO"/>
+          </a:p>
+        </p:txBody>
       </p:sp>
       <p:sp>
         <p:nvSpPr>
@@ -6681,7 +6893,7 @@
           <a:bodyPr wrap="square" lIns="0" tIns="0" rIns="0" bIns="0" rtlCol="0" anchor="ctr"/>
           <a:lstStyle/>
           <a:p>
-            <a:pPr indent="0" marL="0">
+            <a:pPr marL="0" indent="0">
               <a:buNone/>
             </a:pPr>
             <a:r>
@@ -6723,6 +6935,13 @@
             <a:prstDash val="solid"/>
           </a:ln>
         </p:spPr>
+        <p:txBody>
+          <a:bodyPr/>
+          <a:lstStyle/>
+          <a:p>
+            <a:endParaRPr lang="es-CO"/>
+          </a:p>
+        </p:txBody>
       </p:sp>
       <p:sp>
         <p:nvSpPr>
@@ -6748,6 +6967,13 @@
             <a:prstDash val="solid"/>
           </a:ln>
         </p:spPr>
+        <p:txBody>
+          <a:bodyPr/>
+          <a:lstStyle/>
+          <a:p>
+            <a:endParaRPr lang="es-CO"/>
+          </a:p>
+        </p:txBody>
       </p:sp>
       <p:sp>
         <p:nvSpPr>
@@ -6770,7 +6996,7 @@
           <a:bodyPr wrap="square" rtlCol="0" anchor="ctr"/>
           <a:lstStyle/>
           <a:p>
-            <a:pPr indent="0" marL="0">
+            <a:pPr marL="0" indent="0">
               <a:buNone/>
             </a:pPr>
             <a:r>
@@ -6812,6 +7038,13 @@
             <a:prstDash val="solid"/>
           </a:ln>
         </p:spPr>
+        <p:txBody>
+          <a:bodyPr/>
+          <a:lstStyle/>
+          <a:p>
+            <a:endParaRPr lang="es-CO"/>
+          </a:p>
+        </p:txBody>
       </p:sp>
       <p:sp>
         <p:nvSpPr>
@@ -6834,7 +7067,7 @@
           <a:bodyPr wrap="square" lIns="0" tIns="0" rIns="0" bIns="0" rtlCol="0" anchor="ctr"/>
           <a:lstStyle/>
           <a:p>
-            <a:pPr indent="0" marL="0">
+            <a:pPr marL="0" indent="0">
               <a:buNone/>
             </a:pPr>
             <a:r>
@@ -6873,7 +7106,7 @@
           <a:bodyPr wrap="square" lIns="0" tIns="0" rIns="0" bIns="0" rtlCol="0" anchor="ctr"/>
           <a:lstStyle/>
           <a:p>
-            <a:pPr indent="0" marL="0">
+            <a:pPr marL="0" indent="0">
               <a:buNone/>
             </a:pPr>
             <a:r>
@@ -6912,7 +7145,7 @@
           <a:bodyPr wrap="square" lIns="0" tIns="0" rIns="0" bIns="0" rtlCol="0" anchor="ctr"/>
           <a:lstStyle/>
           <a:p>
-            <a:pPr indent="0" marL="0">
+            <a:pPr marL="0" indent="0">
               <a:buNone/>
             </a:pPr>
             <a:r>
@@ -6951,7 +7184,7 @@
           <a:bodyPr wrap="square" lIns="0" tIns="0" rIns="0" bIns="0" rtlCol="0" anchor="ctr"/>
           <a:lstStyle/>
           <a:p>
-            <a:pPr indent="0" marL="0">
+            <a:pPr marL="0" indent="0">
               <a:buNone/>
             </a:pPr>
             <a:r>
@@ -6990,7 +7223,7 @@
           <a:bodyPr wrap="square" lIns="0" tIns="0" rIns="0" bIns="0" rtlCol="0" anchor="ctr"/>
           <a:lstStyle/>
           <a:p>
-            <a:pPr indent="0" marL="0">
+            <a:pPr marL="0" indent="0">
               <a:buNone/>
             </a:pPr>
             <a:r>
@@ -7029,7 +7262,7 @@
           <a:bodyPr wrap="square" lIns="0" tIns="0" rIns="0" bIns="0" rtlCol="0" anchor="ctr"/>
           <a:lstStyle/>
           <a:p>
-            <a:pPr indent="0" marL="0">
+            <a:pPr marL="0" indent="0">
               <a:buNone/>
             </a:pPr>
             <a:r>
@@ -7068,7 +7301,7 @@
           <a:bodyPr wrap="square" lIns="0" tIns="0" rIns="0" bIns="0" rtlCol="0" anchor="ctr"/>
           <a:lstStyle/>
           <a:p>
-            <a:pPr indent="0" marL="0">
+            <a:pPr marL="0" indent="0">
               <a:buNone/>
             </a:pPr>
             <a:r>
@@ -7107,7 +7340,7 @@
           <a:bodyPr wrap="square" lIns="0" tIns="0" rIns="0" bIns="0" rtlCol="0" anchor="ctr"/>
           <a:lstStyle/>
           <a:p>
-            <a:pPr indent="0" marL="0">
+            <a:pPr marL="0" indent="0">
               <a:buNone/>
             </a:pPr>
             <a:r>
@@ -7146,7 +7379,7 @@
           <a:bodyPr wrap="square" lIns="0" tIns="0" rIns="0" bIns="0" rtlCol="0" anchor="ctr"/>
           <a:lstStyle/>
           <a:p>
-            <a:pPr indent="0" marL="0">
+            <a:pPr marL="0" indent="0">
               <a:buNone/>
             </a:pPr>
             <a:r>
@@ -7185,7 +7418,7 @@
           <a:bodyPr wrap="square" lIns="0" tIns="0" rIns="0" bIns="0" rtlCol="0" anchor="ctr"/>
           <a:lstStyle/>
           <a:p>
-            <a:pPr indent="0" marL="0">
+            <a:pPr marL="0" indent="0">
               <a:buNone/>
             </a:pPr>
             <a:r>
@@ -7224,7 +7457,7 @@
           <a:bodyPr wrap="square" lIns="0" tIns="0" rIns="0" bIns="0" rtlCol="0" anchor="ctr"/>
           <a:lstStyle/>
           <a:p>
-            <a:pPr indent="0" marL="0">
+            <a:pPr marL="0" indent="0">
               <a:buNone/>
             </a:pPr>
             <a:r>
@@ -7263,7 +7496,7 @@
           <a:bodyPr wrap="square" lIns="0" tIns="0" rIns="0" bIns="0" rtlCol="0" anchor="ctr"/>
           <a:lstStyle/>
           <a:p>
-            <a:pPr indent="0" marL="0">
+            <a:pPr marL="0" indent="0">
               <a:buNone/>
             </a:pPr>
             <a:r>
@@ -7302,7 +7535,7 @@
           <a:bodyPr wrap="square" lIns="0" tIns="0" rIns="0" bIns="0" rtlCol="0" anchor="ctr"/>
           <a:lstStyle/>
           <a:p>
-            <a:pPr indent="0" marL="0">
+            <a:pPr marL="0" indent="0">
               <a:buNone/>
             </a:pPr>
             <a:r>
@@ -7341,7 +7574,7 @@
           <a:bodyPr wrap="square" lIns="0" tIns="0" rIns="0" bIns="0" rtlCol="0" anchor="ctr"/>
           <a:lstStyle/>
           <a:p>
-            <a:pPr indent="0" marL="0">
+            <a:pPr marL="0" indent="0">
               <a:buNone/>
             </a:pPr>
             <a:r>
@@ -7380,7 +7613,7 @@
           <a:bodyPr wrap="square" lIns="0" tIns="0" rIns="0" bIns="0" rtlCol="0" anchor="ctr"/>
           <a:lstStyle/>
           <a:p>
-            <a:pPr indent="0" marL="0">
+            <a:pPr marL="0" indent="0">
               <a:buNone/>
             </a:pPr>
             <a:r>
@@ -7447,6 +7680,13 @@
             <a:prstDash val="solid"/>
           </a:ln>
         </p:spPr>
+        <p:txBody>
+          <a:bodyPr/>
+          <a:lstStyle/>
+          <a:p>
+            <a:endParaRPr lang="es-CO"/>
+          </a:p>
+        </p:txBody>
       </p:sp>
       <p:sp>
         <p:nvSpPr>
@@ -7469,7 +7709,7 @@
           <a:bodyPr wrap="square" lIns="0" tIns="0" rIns="0" bIns="0" rtlCol="0" anchor="ctr"/>
           <a:lstStyle/>
           <a:p>
-            <a:pPr indent="0" marL="0">
+            <a:pPr marL="0" indent="0">
               <a:buNone/>
             </a:pPr>
             <a:r>
@@ -7511,6 +7751,13 @@
             <a:prstDash val="solid"/>
           </a:ln>
         </p:spPr>
+        <p:txBody>
+          <a:bodyPr/>
+          <a:lstStyle/>
+          <a:p>
+            <a:endParaRPr lang="es-CO"/>
+          </a:p>
+        </p:txBody>
       </p:sp>
       <p:sp>
         <p:nvSpPr>
@@ -7536,6 +7783,13 @@
             <a:prstDash val="solid"/>
           </a:ln>
         </p:spPr>
+        <p:txBody>
+          <a:bodyPr/>
+          <a:lstStyle/>
+          <a:p>
+            <a:endParaRPr lang="es-CO"/>
+          </a:p>
+        </p:txBody>
       </p:sp>
       <p:sp>
         <p:nvSpPr>
@@ -7558,7 +7812,7 @@
           <a:bodyPr wrap="square" rtlCol="0" anchor="ctr"/>
           <a:lstStyle/>
           <a:p>
-            <a:pPr indent="0" marL="0">
+            <a:pPr marL="0" indent="0">
               <a:buNone/>
             </a:pPr>
             <a:r>
@@ -7600,6 +7854,13 @@
             <a:prstDash val="solid"/>
           </a:ln>
         </p:spPr>
+        <p:txBody>
+          <a:bodyPr/>
+          <a:lstStyle/>
+          <a:p>
+            <a:endParaRPr lang="es-CO"/>
+          </a:p>
+        </p:txBody>
       </p:sp>
       <p:sp>
         <p:nvSpPr>
@@ -7622,7 +7883,7 @@
           <a:bodyPr wrap="square" lIns="0" tIns="0" rIns="0" bIns="0" rtlCol="0" anchor="ctr"/>
           <a:lstStyle/>
           <a:p>
-            <a:pPr algn="ctr" indent="0" marL="0">
+            <a:pPr marL="0" indent="0" algn="ctr">
               <a:buNone/>
             </a:pPr>
             <a:r>
@@ -7662,6 +7923,13 @@
             <a:prstDash val="solid"/>
           </a:ln>
         </p:spPr>
+        <p:txBody>
+          <a:bodyPr/>
+          <a:lstStyle/>
+          <a:p>
+            <a:endParaRPr lang="es-CO"/>
+          </a:p>
+        </p:txBody>
       </p:sp>
       <p:sp>
         <p:nvSpPr>
@@ -7687,6 +7955,13 @@
             <a:prstDash val="solid"/>
           </a:ln>
         </p:spPr>
+        <p:txBody>
+          <a:bodyPr/>
+          <a:lstStyle/>
+          <a:p>
+            <a:endParaRPr lang="es-CO"/>
+          </a:p>
+        </p:txBody>
       </p:sp>
       <p:sp>
         <p:nvSpPr>
@@ -7709,7 +7984,7 @@
           <a:bodyPr wrap="square" lIns="0" tIns="0" rIns="0" bIns="0" rtlCol="0" anchor="ctr"/>
           <a:lstStyle/>
           <a:p>
-            <a:pPr algn="ctr" indent="0" marL="0">
+            <a:pPr marL="0" indent="0" algn="ctr">
               <a:buNone/>
             </a:pPr>
             <a:r>
@@ -7726,7 +8001,7 @@
             <a:endParaRPr lang="en-US" sz="1100" dirty="0"/>
           </a:p>
           <a:p>
-            <a:pPr algn="ctr" indent="0" marL="0">
+            <a:pPr marL="0" indent="0" algn="ctr">
               <a:buNone/>
             </a:pPr>
             <a:r>
@@ -7766,6 +8041,13 @@
             <a:prstDash val="solid"/>
           </a:ln>
         </p:spPr>
+        <p:txBody>
+          <a:bodyPr/>
+          <a:lstStyle/>
+          <a:p>
+            <a:endParaRPr lang="es-CO"/>
+          </a:p>
+        </p:txBody>
       </p:sp>
       <p:sp>
         <p:nvSpPr>
@@ -7791,6 +8073,13 @@
             <a:prstDash val="solid"/>
           </a:ln>
         </p:spPr>
+        <p:txBody>
+          <a:bodyPr/>
+          <a:lstStyle/>
+          <a:p>
+            <a:endParaRPr lang="es-CO"/>
+          </a:p>
+        </p:txBody>
       </p:sp>
       <p:sp>
         <p:nvSpPr>
@@ -7813,7 +8102,7 @@
           <a:bodyPr wrap="square" lIns="0" tIns="0" rIns="0" bIns="0" rtlCol="0" anchor="ctr"/>
           <a:lstStyle/>
           <a:p>
-            <a:pPr algn="ctr" indent="0" marL="0">
+            <a:pPr marL="0" indent="0" algn="ctr">
               <a:buNone/>
             </a:pPr>
             <a:r>
@@ -7830,7 +8119,7 @@
             <a:endParaRPr lang="en-US" sz="1100" dirty="0"/>
           </a:p>
           <a:p>
-            <a:pPr algn="ctr" indent="0" marL="0">
+            <a:pPr marL="0" indent="0" algn="ctr">
               <a:buNone/>
             </a:pPr>
             <a:r>
@@ -7847,7 +8136,7 @@
             <a:endParaRPr lang="en-US" sz="1100" dirty="0"/>
           </a:p>
           <a:p>
-            <a:pPr algn="ctr" indent="0" marL="0">
+            <a:pPr marL="0" indent="0" algn="ctr">
               <a:buNone/>
             </a:pPr>
             <a:r>
@@ -7887,6 +8176,13 @@
             <a:prstDash val="solid"/>
           </a:ln>
         </p:spPr>
+        <p:txBody>
+          <a:bodyPr/>
+          <a:lstStyle/>
+          <a:p>
+            <a:endParaRPr lang="es-CO"/>
+          </a:p>
+        </p:txBody>
       </p:sp>
       <p:sp>
         <p:nvSpPr>
@@ -7912,6 +8208,13 @@
             <a:prstDash val="solid"/>
           </a:ln>
         </p:spPr>
+        <p:txBody>
+          <a:bodyPr/>
+          <a:lstStyle/>
+          <a:p>
+            <a:endParaRPr lang="es-CO"/>
+          </a:p>
+        </p:txBody>
       </p:sp>
       <p:sp>
         <p:nvSpPr>
@@ -7934,7 +8237,7 @@
           <a:bodyPr wrap="square" lIns="0" tIns="0" rIns="0" bIns="0" rtlCol="0" anchor="ctr"/>
           <a:lstStyle/>
           <a:p>
-            <a:pPr algn="ctr" indent="0" marL="0">
+            <a:pPr marL="0" indent="0" algn="ctr">
               <a:buNone/>
             </a:pPr>
             <a:r>
@@ -7974,6 +8277,13 @@
             <a:prstDash val="solid"/>
           </a:ln>
         </p:spPr>
+        <p:txBody>
+          <a:bodyPr/>
+          <a:lstStyle/>
+          <a:p>
+            <a:endParaRPr lang="es-CO"/>
+          </a:p>
+        </p:txBody>
       </p:sp>
       <p:sp>
         <p:nvSpPr>
@@ -7999,6 +8309,13 @@
             <a:prstDash val="solid"/>
           </a:ln>
         </p:spPr>
+        <p:txBody>
+          <a:bodyPr/>
+          <a:lstStyle/>
+          <a:p>
+            <a:endParaRPr lang="es-CO"/>
+          </a:p>
+        </p:txBody>
       </p:sp>
       <p:sp>
         <p:nvSpPr>
@@ -8021,7 +8338,7 @@
           <a:bodyPr wrap="square" lIns="0" tIns="0" rIns="0" bIns="0" rtlCol="0" anchor="ctr"/>
           <a:lstStyle/>
           <a:p>
-            <a:pPr algn="ctr" indent="0" marL="0">
+            <a:pPr marL="0" indent="0" algn="ctr">
               <a:buNone/>
             </a:pPr>
             <a:r>
@@ -8038,7 +8355,7 @@
             <a:endParaRPr lang="en-US" sz="1100" dirty="0"/>
           </a:p>
           <a:p>
-            <a:pPr algn="ctr" indent="0" marL="0">
+            <a:pPr marL="0" indent="0" algn="ctr">
               <a:buNone/>
             </a:pPr>
             <a:r>
@@ -8080,6 +8397,13 @@
             <a:prstDash val="solid"/>
           </a:ln>
         </p:spPr>
+        <p:txBody>
+          <a:bodyPr/>
+          <a:lstStyle/>
+          <a:p>
+            <a:endParaRPr lang="es-CO"/>
+          </a:p>
+        </p:txBody>
       </p:sp>
       <p:sp>
         <p:nvSpPr>
@@ -8102,7 +8426,7 @@
           <a:bodyPr wrap="square" lIns="0" tIns="0" rIns="0" bIns="0" rtlCol="0" anchor="ctr"/>
           <a:lstStyle/>
           <a:p>
-            <a:pPr algn="ctr" indent="0" marL="0">
+            <a:pPr marL="0" indent="0" algn="ctr">
               <a:buNone/>
             </a:pPr>
             <a:r>
@@ -8119,7 +8443,7 @@
             <a:endParaRPr lang="en-US" sz="1100" dirty="0"/>
           </a:p>
           <a:p>
-            <a:pPr algn="ctr" indent="0" marL="0">
+            <a:pPr marL="0" indent="0" algn="ctr">
               <a:buNone/>
             </a:pPr>
             <a:r>
@@ -8136,7 +8460,7 @@
             <a:endParaRPr lang="en-US" sz="1100" dirty="0"/>
           </a:p>
           <a:p>
-            <a:pPr algn="ctr" indent="0" marL="0">
+            <a:pPr marL="0" indent="0" algn="ctr">
               <a:buNone/>
             </a:pPr>
             <a:r>
@@ -8176,6 +8500,13 @@
             <a:prstDash val="solid"/>
           </a:ln>
         </p:spPr>
+        <p:txBody>
+          <a:bodyPr/>
+          <a:lstStyle/>
+          <a:p>
+            <a:endParaRPr lang="es-CO"/>
+          </a:p>
+        </p:txBody>
       </p:sp>
       <p:sp>
         <p:nvSpPr>
@@ -8201,6 +8532,13 @@
             <a:prstDash val="solid"/>
           </a:ln>
         </p:spPr>
+        <p:txBody>
+          <a:bodyPr/>
+          <a:lstStyle/>
+          <a:p>
+            <a:endParaRPr lang="es-CO"/>
+          </a:p>
+        </p:txBody>
       </p:sp>
       <p:sp>
         <p:nvSpPr>
@@ -8223,7 +8561,7 @@
           <a:bodyPr wrap="square" lIns="0" tIns="0" rIns="0" bIns="0" rtlCol="0" anchor="ctr"/>
           <a:lstStyle/>
           <a:p>
-            <a:pPr algn="ctr" indent="0" marL="0">
+            <a:pPr marL="0" indent="0" algn="ctr">
               <a:buNone/>
             </a:pPr>
             <a:r>
@@ -8263,6 +8601,13 @@
             <a:prstDash val="solid"/>
           </a:ln>
         </p:spPr>
+        <p:txBody>
+          <a:bodyPr/>
+          <a:lstStyle/>
+          <a:p>
+            <a:endParaRPr lang="es-CO"/>
+          </a:p>
+        </p:txBody>
       </p:sp>
       <p:sp>
         <p:nvSpPr>
@@ -8288,6 +8633,13 @@
             <a:prstDash val="solid"/>
           </a:ln>
         </p:spPr>
+        <p:txBody>
+          <a:bodyPr/>
+          <a:lstStyle/>
+          <a:p>
+            <a:endParaRPr lang="es-CO"/>
+          </a:p>
+        </p:txBody>
       </p:sp>
       <p:sp>
         <p:nvSpPr>
@@ -8310,7 +8662,7 @@
           <a:bodyPr wrap="square" lIns="0" tIns="0" rIns="0" bIns="0" rtlCol="0" anchor="ctr"/>
           <a:lstStyle/>
           <a:p>
-            <a:pPr algn="ctr" indent="0" marL="0">
+            <a:pPr marL="0" indent="0" algn="ctr">
               <a:buNone/>
             </a:pPr>
             <a:r>
@@ -8327,7 +8679,7 @@
             <a:endParaRPr lang="en-US" sz="1100" dirty="0"/>
           </a:p>
           <a:p>
-            <a:pPr algn="ctr" indent="0" marL="0">
+            <a:pPr marL="0" indent="0" algn="ctr">
               <a:buNone/>
             </a:pPr>
             <a:r>
@@ -8367,6 +8719,13 @@
             <a:prstDash val="solid"/>
           </a:ln>
         </p:spPr>
+        <p:txBody>
+          <a:bodyPr/>
+          <a:lstStyle/>
+          <a:p>
+            <a:endParaRPr lang="es-CO"/>
+          </a:p>
+        </p:txBody>
       </p:sp>
       <p:sp>
         <p:nvSpPr>
@@ -8392,6 +8751,13 @@
             <a:prstDash val="solid"/>
           </a:ln>
         </p:spPr>
+        <p:txBody>
+          <a:bodyPr/>
+          <a:lstStyle/>
+          <a:p>
+            <a:endParaRPr lang="es-CO"/>
+          </a:p>
+        </p:txBody>
       </p:sp>
       <p:sp>
         <p:nvSpPr>
@@ -8414,7 +8780,7 @@
           <a:bodyPr wrap="square" lIns="0" tIns="0" rIns="0" bIns="0" rtlCol="0" anchor="ctr"/>
           <a:lstStyle/>
           <a:p>
-            <a:pPr algn="ctr" indent="0" marL="0">
+            <a:pPr marL="0" indent="0" algn="ctr">
               <a:buNone/>
             </a:pPr>
             <a:r>
@@ -8453,7 +8819,7 @@
           <a:bodyPr wrap="square" rtlCol="0" anchor="ctr"/>
           <a:lstStyle/>
           <a:p>
-            <a:pPr indent="0" marL="0">
+            <a:pPr marL="0" indent="0">
               <a:buNone/>
             </a:pPr>
             <a:r>
@@ -8492,7 +8858,7 @@
           <a:bodyPr wrap="square" rtlCol="0" anchor="ctr"/>
           <a:lstStyle/>
           <a:p>
-            <a:pPr indent="0" marL="0">
+            <a:pPr marL="0" indent="0">
               <a:buNone/>
             </a:pPr>
             <a:r>
@@ -8531,7 +8897,7 @@
           <a:bodyPr wrap="square" rtlCol="0" anchor="ctr"/>
           <a:lstStyle/>
           <a:p>
-            <a:pPr indent="0" marL="0">
+            <a:pPr marL="0" indent="0">
               <a:buNone/>
             </a:pPr>
             <a:r>
@@ -8573,6 +8939,13 @@
             <a:prstDash val="solid"/>
           </a:ln>
         </p:spPr>
+        <p:txBody>
+          <a:bodyPr/>
+          <a:lstStyle/>
+          <a:p>
+            <a:endParaRPr lang="es-CO"/>
+          </a:p>
+        </p:txBody>
       </p:sp>
       <p:sp>
         <p:nvSpPr>
@@ -8595,7 +8968,7 @@
           <a:bodyPr wrap="square" rtlCol="0" anchor="ctr"/>
           <a:lstStyle/>
           <a:p>
-            <a:pPr indent="0" marL="0">
+            <a:pPr marL="0" indent="0">
               <a:buNone/>
             </a:pPr>
             <a:r>
@@ -8634,7 +9007,7 @@
           <a:bodyPr wrap="square" lIns="0" tIns="0" rIns="0" bIns="0" rtlCol="0" anchor="ctr"/>
           <a:lstStyle/>
           <a:p>
-            <a:pPr indent="0" marL="0">
+            <a:pPr marL="0" indent="0">
               <a:buNone/>
             </a:pPr>
             <a:r>
@@ -8673,7 +9046,7 @@
           <a:bodyPr wrap="square" lIns="0" tIns="0" rIns="0" bIns="0" rtlCol="0" anchor="ctr"/>
           <a:lstStyle/>
           <a:p>
-            <a:pPr indent="0" marL="0">
+            <a:pPr marL="0" indent="0">
               <a:buNone/>
             </a:pPr>
             <a:r>
@@ -8712,7 +9085,7 @@
           <a:bodyPr wrap="square" lIns="0" tIns="0" rIns="0" bIns="0" rtlCol="0" anchor="ctr"/>
           <a:lstStyle/>
           <a:p>
-            <a:pPr indent="0" marL="0">
+            <a:pPr marL="0" indent="0">
               <a:buNone/>
             </a:pPr>
             <a:endParaRPr lang="en-US" sz="1100" dirty="0"/>
@@ -8740,7 +9113,7 @@
           <a:bodyPr wrap="square" lIns="0" tIns="0" rIns="0" bIns="0" rtlCol="0" anchor="ctr"/>
           <a:lstStyle/>
           <a:p>
-            <a:pPr indent="0" marL="0">
+            <a:pPr marL="0" indent="0">
               <a:buNone/>
             </a:pPr>
             <a:r>
@@ -8779,7 +9152,7 @@
           <a:bodyPr wrap="square" lIns="0" tIns="0" rIns="0" bIns="0" rtlCol="0" anchor="ctr"/>
           <a:lstStyle/>
           <a:p>
-            <a:pPr indent="0" marL="0">
+            <a:pPr marL="0" indent="0">
               <a:buNone/>
             </a:pPr>
             <a:r>
@@ -8818,7 +9191,7 @@
           <a:bodyPr wrap="square" lIns="0" tIns="0" rIns="0" bIns="0" rtlCol="0" anchor="ctr"/>
           <a:lstStyle/>
           <a:p>
-            <a:pPr indent="0" marL="0">
+            <a:pPr marL="0" indent="0">
               <a:buNone/>
             </a:pPr>
             <a:r>
@@ -8857,7 +9230,7 @@
           <a:bodyPr wrap="square" lIns="0" tIns="0" rIns="0" bIns="0" rtlCol="0" anchor="ctr"/>
           <a:lstStyle/>
           <a:p>
-            <a:pPr indent="0" marL="0">
+            <a:pPr marL="0" indent="0">
               <a:buNone/>
             </a:pPr>
             <a:r>
@@ -8896,7 +9269,7 @@
           <a:bodyPr wrap="square" lIns="0" tIns="0" rIns="0" bIns="0" rtlCol="0" anchor="ctr"/>
           <a:lstStyle/>
           <a:p>
-            <a:pPr indent="0" marL="0">
+            <a:pPr marL="0" indent="0">
               <a:buNone/>
             </a:pPr>
             <a:endParaRPr lang="en-US" sz="1100" dirty="0"/>
@@ -8924,7 +9297,7 @@
           <a:bodyPr wrap="square" lIns="0" tIns="0" rIns="0" bIns="0" rtlCol="0" anchor="ctr"/>
           <a:lstStyle/>
           <a:p>
-            <a:pPr indent="0" marL="0">
+            <a:pPr marL="0" indent="0">
               <a:buNone/>
             </a:pPr>
             <a:r>
@@ -8963,7 +9336,7 @@
           <a:bodyPr wrap="square" lIns="0" tIns="0" rIns="0" bIns="0" rtlCol="0" anchor="ctr"/>
           <a:lstStyle/>
           <a:p>
-            <a:pPr indent="0" marL="0">
+            <a:pPr marL="0" indent="0">
               <a:buNone/>
             </a:pPr>
             <a:r>
@@ -9002,7 +9375,7 @@
           <a:bodyPr wrap="square" lIns="0" tIns="0" rIns="0" bIns="0" rtlCol="0" anchor="ctr"/>
           <a:lstStyle/>
           <a:p>
-            <a:pPr indent="0" marL="0">
+            <a:pPr marL="0" indent="0">
               <a:buNone/>
             </a:pPr>
             <a:r>
@@ -9069,6 +9442,13 @@
             <a:prstDash val="solid"/>
           </a:ln>
         </p:spPr>
+        <p:txBody>
+          <a:bodyPr/>
+          <a:lstStyle/>
+          <a:p>
+            <a:endParaRPr lang="es-CO"/>
+          </a:p>
+        </p:txBody>
       </p:sp>
       <p:sp>
         <p:nvSpPr>
@@ -9091,7 +9471,7 @@
           <a:bodyPr wrap="square" lIns="0" tIns="0" rIns="0" bIns="0" rtlCol="0" anchor="ctr"/>
           <a:lstStyle/>
           <a:p>
-            <a:pPr indent="0" marL="0">
+            <a:pPr marL="0" indent="0">
               <a:buNone/>
             </a:pPr>
             <a:r>
@@ -9133,6 +9513,13 @@
             <a:prstDash val="solid"/>
           </a:ln>
         </p:spPr>
+        <p:txBody>
+          <a:bodyPr/>
+          <a:lstStyle/>
+          <a:p>
+            <a:endParaRPr lang="es-CO"/>
+          </a:p>
+        </p:txBody>
       </p:sp>
       <p:sp>
         <p:nvSpPr>
@@ -9158,6 +9545,13 @@
             <a:prstDash val="solid"/>
           </a:ln>
         </p:spPr>
+        <p:txBody>
+          <a:bodyPr/>
+          <a:lstStyle/>
+          <a:p>
+            <a:endParaRPr lang="es-CO"/>
+          </a:p>
+        </p:txBody>
       </p:sp>
       <p:sp>
         <p:nvSpPr>
@@ -9180,7 +9574,7 @@
           <a:bodyPr wrap="square" rtlCol="0" anchor="ctr"/>
           <a:lstStyle/>
           <a:p>
-            <a:pPr indent="0" marL="0">
+            <a:pPr marL="0" indent="0">
               <a:buNone/>
             </a:pPr>
             <a:r>
@@ -9222,6 +9616,13 @@
             <a:prstDash val="solid"/>
           </a:ln>
         </p:spPr>
+        <p:txBody>
+          <a:bodyPr/>
+          <a:lstStyle/>
+          <a:p>
+            <a:endParaRPr lang="es-CO"/>
+          </a:p>
+        </p:txBody>
       </p:sp>
       <p:sp>
         <p:nvSpPr>
@@ -9247,6 +9648,13 @@
             <a:prstDash val="solid"/>
           </a:ln>
         </p:spPr>
+        <p:txBody>
+          <a:bodyPr/>
+          <a:lstStyle/>
+          <a:p>
+            <a:endParaRPr lang="es-CO"/>
+          </a:p>
+        </p:txBody>
       </p:sp>
       <p:sp>
         <p:nvSpPr>
@@ -9269,7 +9677,7 @@
           <a:bodyPr wrap="square" lIns="0" tIns="0" rIns="0" bIns="0" rtlCol="0" anchor="ctr"/>
           <a:lstStyle/>
           <a:p>
-            <a:pPr indent="0" marL="0">
+            <a:pPr marL="0" indent="0">
               <a:buNone/>
             </a:pPr>
             <a:r>
@@ -9308,7 +9716,7 @@
           <a:bodyPr wrap="square" lIns="0" tIns="0" rIns="0" bIns="0" rtlCol="0" anchor="ctr"/>
           <a:lstStyle/>
           <a:p>
-            <a:pPr indent="0" marL="0">
+            <a:pPr marL="0" indent="0">
               <a:buNone/>
             </a:pPr>
             <a:r>
@@ -9350,6 +9758,13 @@
             <a:prstDash val="solid"/>
           </a:ln>
         </p:spPr>
+        <p:txBody>
+          <a:bodyPr/>
+          <a:lstStyle/>
+          <a:p>
+            <a:endParaRPr lang="es-CO"/>
+          </a:p>
+        </p:txBody>
       </p:sp>
       <p:sp>
         <p:nvSpPr>
@@ -9375,6 +9790,13 @@
             <a:prstDash val="solid"/>
           </a:ln>
         </p:spPr>
+        <p:txBody>
+          <a:bodyPr/>
+          <a:lstStyle/>
+          <a:p>
+            <a:endParaRPr lang="es-CO"/>
+          </a:p>
+        </p:txBody>
       </p:sp>
       <p:sp>
         <p:nvSpPr>
@@ -9397,7 +9819,7 @@
           <a:bodyPr wrap="square" lIns="0" tIns="0" rIns="0" bIns="0" rtlCol="0" anchor="ctr"/>
           <a:lstStyle/>
           <a:p>
-            <a:pPr indent="0" marL="0">
+            <a:pPr marL="0" indent="0">
               <a:buNone/>
             </a:pPr>
             <a:r>
@@ -9436,7 +9858,7 @@
           <a:bodyPr wrap="square" lIns="0" tIns="0" rIns="0" bIns="0" rtlCol="0" anchor="ctr"/>
           <a:lstStyle/>
           <a:p>
-            <a:pPr indent="0" marL="0">
+            <a:pPr marL="0" indent="0">
               <a:buNone/>
             </a:pPr>
             <a:r>
@@ -9478,6 +9900,13 @@
             <a:prstDash val="solid"/>
           </a:ln>
         </p:spPr>
+        <p:txBody>
+          <a:bodyPr/>
+          <a:lstStyle/>
+          <a:p>
+            <a:endParaRPr lang="es-CO"/>
+          </a:p>
+        </p:txBody>
       </p:sp>
       <p:sp>
         <p:nvSpPr>
@@ -9503,6 +9932,13 @@
             <a:prstDash val="solid"/>
           </a:ln>
         </p:spPr>
+        <p:txBody>
+          <a:bodyPr/>
+          <a:lstStyle/>
+          <a:p>
+            <a:endParaRPr lang="es-CO"/>
+          </a:p>
+        </p:txBody>
       </p:sp>
       <p:sp>
         <p:nvSpPr>
@@ -9525,7 +9961,7 @@
           <a:bodyPr wrap="square" lIns="0" tIns="0" rIns="0" bIns="0" rtlCol="0" anchor="ctr"/>
           <a:lstStyle/>
           <a:p>
-            <a:pPr indent="0" marL="0">
+            <a:pPr marL="0" indent="0">
               <a:buNone/>
             </a:pPr>
             <a:r>
@@ -9564,7 +10000,7 @@
           <a:bodyPr wrap="square" lIns="0" tIns="0" rIns="0" bIns="0" rtlCol="0" anchor="ctr"/>
           <a:lstStyle/>
           <a:p>
-            <a:pPr indent="0" marL="0">
+            <a:pPr marL="0" indent="0">
               <a:buNone/>
             </a:pPr>
             <a:r>
@@ -9606,6 +10042,13 @@
             <a:prstDash val="solid"/>
           </a:ln>
         </p:spPr>
+        <p:txBody>
+          <a:bodyPr/>
+          <a:lstStyle/>
+          <a:p>
+            <a:endParaRPr lang="es-CO"/>
+          </a:p>
+        </p:txBody>
       </p:sp>
       <p:sp>
         <p:nvSpPr>
@@ -9631,6 +10074,13 @@
             <a:prstDash val="solid"/>
           </a:ln>
         </p:spPr>
+        <p:txBody>
+          <a:bodyPr/>
+          <a:lstStyle/>
+          <a:p>
+            <a:endParaRPr lang="es-CO"/>
+          </a:p>
+        </p:txBody>
       </p:sp>
       <p:sp>
         <p:nvSpPr>
@@ -9653,7 +10103,7 @@
           <a:bodyPr wrap="square" lIns="0" tIns="0" rIns="0" bIns="0" rtlCol="0" anchor="ctr"/>
           <a:lstStyle/>
           <a:p>
-            <a:pPr indent="0" marL="0">
+            <a:pPr marL="0" indent="0">
               <a:buNone/>
             </a:pPr>
             <a:r>
@@ -9692,7 +10142,7 @@
           <a:bodyPr wrap="square" lIns="0" tIns="0" rIns="0" bIns="0" rtlCol="0" anchor="ctr"/>
           <a:lstStyle/>
           <a:p>
-            <a:pPr indent="0" marL="0">
+            <a:pPr marL="0" indent="0">
               <a:buNone/>
             </a:pPr>
             <a:r>
@@ -9734,6 +10184,13 @@
             <a:prstDash val="solid"/>
           </a:ln>
         </p:spPr>
+        <p:txBody>
+          <a:bodyPr/>
+          <a:lstStyle/>
+          <a:p>
+            <a:endParaRPr lang="es-CO"/>
+          </a:p>
+        </p:txBody>
       </p:sp>
       <p:sp>
         <p:nvSpPr>
@@ -9759,6 +10216,13 @@
             <a:prstDash val="solid"/>
           </a:ln>
         </p:spPr>
+        <p:txBody>
+          <a:bodyPr/>
+          <a:lstStyle/>
+          <a:p>
+            <a:endParaRPr lang="es-CO"/>
+          </a:p>
+        </p:txBody>
       </p:sp>
       <p:sp>
         <p:nvSpPr>
@@ -9781,7 +10245,7 @@
           <a:bodyPr wrap="square" lIns="0" tIns="0" rIns="0" bIns="0" rtlCol="0" anchor="ctr"/>
           <a:lstStyle/>
           <a:p>
-            <a:pPr indent="0" marL="0">
+            <a:pPr marL="0" indent="0">
               <a:buNone/>
             </a:pPr>
             <a:r>
@@ -9820,7 +10284,7 @@
           <a:bodyPr wrap="square" lIns="0" tIns="0" rIns="0" bIns="0" rtlCol="0" anchor="ctr"/>
           <a:lstStyle/>
           <a:p>
-            <a:pPr indent="0" marL="0">
+            <a:pPr marL="0" indent="0">
               <a:buNone/>
             </a:pPr>
             <a:r>
@@ -9862,6 +10326,13 @@
             <a:prstDash val="solid"/>
           </a:ln>
         </p:spPr>
+        <p:txBody>
+          <a:bodyPr/>
+          <a:lstStyle/>
+          <a:p>
+            <a:endParaRPr lang="es-CO"/>
+          </a:p>
+        </p:txBody>
       </p:sp>
       <p:sp>
         <p:nvSpPr>
@@ -9887,6 +10358,13 @@
             <a:prstDash val="solid"/>
           </a:ln>
         </p:spPr>
+        <p:txBody>
+          <a:bodyPr/>
+          <a:lstStyle/>
+          <a:p>
+            <a:endParaRPr lang="es-CO"/>
+          </a:p>
+        </p:txBody>
       </p:sp>
       <p:sp>
         <p:nvSpPr>
@@ -9909,7 +10387,7 @@
           <a:bodyPr wrap="square" lIns="0" tIns="0" rIns="0" bIns="0" rtlCol="0" anchor="ctr"/>
           <a:lstStyle/>
           <a:p>
-            <a:pPr indent="0" marL="0">
+            <a:pPr marL="0" indent="0">
               <a:buNone/>
             </a:pPr>
             <a:r>
@@ -9948,7 +10426,7 @@
           <a:bodyPr wrap="square" lIns="0" tIns="0" rIns="0" bIns="0" rtlCol="0" anchor="ctr"/>
           <a:lstStyle/>
           <a:p>
-            <a:pPr indent="0" marL="0">
+            <a:pPr marL="0" indent="0">
               <a:buNone/>
             </a:pPr>
             <a:r>
@@ -9990,6 +10468,13 @@
             <a:prstDash val="solid"/>
           </a:ln>
         </p:spPr>
+        <p:txBody>
+          <a:bodyPr/>
+          <a:lstStyle/>
+          <a:p>
+            <a:endParaRPr lang="es-CO"/>
+          </a:p>
+        </p:txBody>
       </p:sp>
       <p:sp>
         <p:nvSpPr>
@@ -10015,6 +10500,13 @@
             <a:prstDash val="solid"/>
           </a:ln>
         </p:spPr>
+        <p:txBody>
+          <a:bodyPr/>
+          <a:lstStyle/>
+          <a:p>
+            <a:endParaRPr lang="es-CO"/>
+          </a:p>
+        </p:txBody>
       </p:sp>
       <p:sp>
         <p:nvSpPr>
@@ -10037,7 +10529,7 @@
           <a:bodyPr wrap="square" lIns="0" tIns="0" rIns="0" bIns="0" rtlCol="0" anchor="ctr"/>
           <a:lstStyle/>
           <a:p>
-            <a:pPr indent="0" marL="0">
+            <a:pPr marL="0" indent="0">
               <a:buNone/>
             </a:pPr>
             <a:r>
@@ -10076,7 +10568,7 @@
           <a:bodyPr wrap="square" lIns="0" tIns="0" rIns="0" bIns="0" rtlCol="0" anchor="ctr"/>
           <a:lstStyle/>
           <a:p>
-            <a:pPr indent="0" marL="0">
+            <a:pPr marL="0" indent="0">
               <a:buNone/>
             </a:pPr>
             <a:r>
@@ -10118,6 +10610,13 @@
             <a:prstDash val="solid"/>
           </a:ln>
         </p:spPr>
+        <p:txBody>
+          <a:bodyPr/>
+          <a:lstStyle/>
+          <a:p>
+            <a:endParaRPr lang="es-CO"/>
+          </a:p>
+        </p:txBody>
       </p:sp>
       <p:sp>
         <p:nvSpPr>
@@ -10143,6 +10642,13 @@
             <a:prstDash val="solid"/>
           </a:ln>
         </p:spPr>
+        <p:txBody>
+          <a:bodyPr/>
+          <a:lstStyle/>
+          <a:p>
+            <a:endParaRPr lang="es-CO"/>
+          </a:p>
+        </p:txBody>
       </p:sp>
       <p:sp>
         <p:nvSpPr>
@@ -10165,7 +10671,7 @@
           <a:bodyPr wrap="square" lIns="0" tIns="0" rIns="0" bIns="0" rtlCol="0" anchor="ctr"/>
           <a:lstStyle/>
           <a:p>
-            <a:pPr indent="0" marL="0">
+            <a:pPr marL="0" indent="0">
               <a:buNone/>
             </a:pPr>
             <a:r>
@@ -10204,7 +10710,7 @@
           <a:bodyPr wrap="square" lIns="0" tIns="0" rIns="0" bIns="0" rtlCol="0" anchor="ctr"/>
           <a:lstStyle/>
           <a:p>
-            <a:pPr indent="0" marL="0">
+            <a:pPr marL="0" indent="0">
               <a:buNone/>
             </a:pPr>
             <a:r>
@@ -10271,6 +10777,13 @@
             <a:prstDash val="solid"/>
           </a:ln>
         </p:spPr>
+        <p:txBody>
+          <a:bodyPr/>
+          <a:lstStyle/>
+          <a:p>
+            <a:endParaRPr lang="es-CO"/>
+          </a:p>
+        </p:txBody>
       </p:sp>
       <p:sp>
         <p:nvSpPr>
@@ -10293,7 +10806,7 @@
           <a:bodyPr wrap="square" lIns="0" tIns="0" rIns="0" bIns="0" rtlCol="0" anchor="ctr"/>
           <a:lstStyle/>
           <a:p>
-            <a:pPr indent="0" marL="0">
+            <a:pPr marL="0" indent="0">
               <a:buNone/>
             </a:pPr>
             <a:r>
@@ -10335,6 +10848,13 @@
             <a:prstDash val="solid"/>
           </a:ln>
         </p:spPr>
+        <p:txBody>
+          <a:bodyPr/>
+          <a:lstStyle/>
+          <a:p>
+            <a:endParaRPr lang="es-CO"/>
+          </a:p>
+        </p:txBody>
       </p:sp>
       <p:sp>
         <p:nvSpPr>
@@ -10360,6 +10880,13 @@
             <a:prstDash val="solid"/>
           </a:ln>
         </p:spPr>
+        <p:txBody>
+          <a:bodyPr/>
+          <a:lstStyle/>
+          <a:p>
+            <a:endParaRPr lang="es-CO"/>
+          </a:p>
+        </p:txBody>
       </p:sp>
       <p:sp>
         <p:nvSpPr>
@@ -10382,7 +10909,7 @@
           <a:bodyPr wrap="square" rtlCol="0" anchor="ctr"/>
           <a:lstStyle/>
           <a:p>
-            <a:pPr indent="0" marL="0">
+            <a:pPr marL="0" indent="0">
               <a:buNone/>
             </a:pPr>
             <a:r>
@@ -10424,6 +10951,13 @@
             <a:prstDash val="solid"/>
           </a:ln>
         </p:spPr>
+        <p:txBody>
+          <a:bodyPr/>
+          <a:lstStyle/>
+          <a:p>
+            <a:endParaRPr lang="es-CO"/>
+          </a:p>
+        </p:txBody>
       </p:sp>
       <p:sp>
         <p:nvSpPr>
@@ -10446,7 +10980,7 @@
           <a:bodyPr wrap="square" lIns="0" tIns="0" rIns="0" bIns="0" rtlCol="0" anchor="ctr"/>
           <a:lstStyle/>
           <a:p>
-            <a:pPr indent="0" marL="0">
+            <a:pPr marL="0" indent="0">
               <a:buNone/>
             </a:pPr>
             <a:r>
@@ -10485,7 +11019,7 @@
           <a:bodyPr wrap="square" lIns="0" tIns="0" rIns="0" bIns="0" rtlCol="0" anchor="ctr"/>
           <a:lstStyle/>
           <a:p>
-            <a:pPr indent="0" marL="0">
+            <a:pPr marL="0" indent="0">
               <a:buNone/>
             </a:pPr>
             <a:r>
@@ -10527,6 +11061,13 @@
             <a:prstDash val="solid"/>
           </a:ln>
         </p:spPr>
+        <p:txBody>
+          <a:bodyPr/>
+          <a:lstStyle/>
+          <a:p>
+            <a:endParaRPr lang="es-CO"/>
+          </a:p>
+        </p:txBody>
       </p:sp>
       <p:sp>
         <p:nvSpPr>
@@ -10549,7 +11090,7 @@
           <a:bodyPr wrap="square" lIns="0" tIns="0" rIns="0" bIns="0" rtlCol="0" anchor="ctr"/>
           <a:lstStyle/>
           <a:p>
-            <a:pPr indent="0" marL="0">
+            <a:pPr marL="0" indent="0">
               <a:buNone/>
             </a:pPr>
             <a:r>
@@ -10588,7 +11129,7 @@
           <a:bodyPr wrap="square" lIns="0" tIns="0" rIns="0" bIns="0" rtlCol="0" anchor="ctr"/>
           <a:lstStyle/>
           <a:p>
-            <a:pPr indent="0" marL="0">
+            <a:pPr marL="0" indent="0">
               <a:buNone/>
             </a:pPr>
             <a:r>
@@ -10630,6 +11171,13 @@
             <a:prstDash val="solid"/>
           </a:ln>
         </p:spPr>
+        <p:txBody>
+          <a:bodyPr/>
+          <a:lstStyle/>
+          <a:p>
+            <a:endParaRPr lang="es-CO"/>
+          </a:p>
+        </p:txBody>
       </p:sp>
       <p:sp>
         <p:nvSpPr>
@@ -10652,7 +11200,7 @@
           <a:bodyPr wrap="square" lIns="0" tIns="0" rIns="0" bIns="0" rtlCol="0" anchor="ctr"/>
           <a:lstStyle/>
           <a:p>
-            <a:pPr indent="0" marL="0">
+            <a:pPr marL="0" indent="0">
               <a:buNone/>
             </a:pPr>
             <a:r>
@@ -10691,7 +11239,7 @@
           <a:bodyPr wrap="square" lIns="0" tIns="0" rIns="0" bIns="0" rtlCol="0" anchor="ctr"/>
           <a:lstStyle/>
           <a:p>
-            <a:pPr indent="0" marL="0">
+            <a:pPr marL="0" indent="0">
               <a:buNone/>
             </a:pPr>
             <a:r>
@@ -10733,6 +11281,13 @@
             <a:prstDash val="solid"/>
           </a:ln>
         </p:spPr>
+        <p:txBody>
+          <a:bodyPr/>
+          <a:lstStyle/>
+          <a:p>
+            <a:endParaRPr lang="es-CO"/>
+          </a:p>
+        </p:txBody>
       </p:sp>
       <p:sp>
         <p:nvSpPr>
@@ -10755,7 +11310,7 @@
           <a:bodyPr wrap="square" lIns="0" tIns="0" rIns="0" bIns="0" rtlCol="0" anchor="ctr"/>
           <a:lstStyle/>
           <a:p>
-            <a:pPr indent="0" marL="0">
+            <a:pPr marL="0" indent="0">
               <a:buNone/>
             </a:pPr>
             <a:r>
@@ -10794,7 +11349,7 @@
           <a:bodyPr wrap="square" lIns="0" tIns="0" rIns="0" bIns="0" rtlCol="0" anchor="ctr"/>
           <a:lstStyle/>
           <a:p>
-            <a:pPr indent="0" marL="0">
+            <a:pPr marL="0" indent="0">
               <a:buNone/>
             </a:pPr>
             <a:r>
@@ -10836,6 +11391,13 @@
             <a:prstDash val="solid"/>
           </a:ln>
         </p:spPr>
+        <p:txBody>
+          <a:bodyPr/>
+          <a:lstStyle/>
+          <a:p>
+            <a:endParaRPr lang="es-CO"/>
+          </a:p>
+        </p:txBody>
       </p:sp>
       <p:sp>
         <p:nvSpPr>
@@ -10858,7 +11420,7 @@
           <a:bodyPr wrap="square" lIns="0" tIns="0" rIns="0" bIns="0" rtlCol="0" anchor="ctr"/>
           <a:lstStyle/>
           <a:p>
-            <a:pPr indent="0" marL="0">
+            <a:pPr marL="0" indent="0">
               <a:buNone/>
             </a:pPr>
             <a:r>
@@ -10897,7 +11459,7 @@
           <a:bodyPr wrap="square" lIns="0" tIns="0" rIns="0" bIns="0" rtlCol="0" anchor="ctr"/>
           <a:lstStyle/>
           <a:p>
-            <a:pPr indent="0" marL="0">
+            <a:pPr marL="0" indent="0">
               <a:buNone/>
             </a:pPr>
             <a:r>
@@ -10939,6 +11501,13 @@
             <a:prstDash val="solid"/>
           </a:ln>
         </p:spPr>
+        <p:txBody>
+          <a:bodyPr/>
+          <a:lstStyle/>
+          <a:p>
+            <a:endParaRPr lang="es-CO"/>
+          </a:p>
+        </p:txBody>
       </p:sp>
       <p:sp>
         <p:nvSpPr>
@@ -10961,7 +11530,7 @@
           <a:bodyPr wrap="square" rtlCol="0" anchor="ctr"/>
           <a:lstStyle/>
           <a:p>
-            <a:pPr algn="ctr" indent="0" marL="0">
+            <a:pPr marL="0" indent="0" algn="ctr">
               <a:buNone/>
             </a:pPr>
             <a:r>
@@ -11003,6 +11572,13 @@
             <a:prstDash val="solid"/>
           </a:ln>
         </p:spPr>
+        <p:txBody>
+          <a:bodyPr/>
+          <a:lstStyle/>
+          <a:p>
+            <a:endParaRPr lang="es-CO"/>
+          </a:p>
+        </p:txBody>
       </p:sp>
       <p:sp>
         <p:nvSpPr>
@@ -11025,7 +11601,7 @@
           <a:bodyPr wrap="square" rtlCol="0" anchor="ctr"/>
           <a:lstStyle/>
           <a:p>
-            <a:pPr algn="ctr" indent="0" marL="0">
+            <a:pPr marL="0" indent="0" algn="ctr">
               <a:buNone/>
             </a:pPr>
             <a:r>
@@ -11042,7 +11618,7 @@
             <a:endParaRPr lang="en-US" sz="700" dirty="0"/>
           </a:p>
           <a:p>
-            <a:pPr algn="ctr" indent="0" marL="0">
+            <a:pPr marL="0" indent="0" algn="ctr">
               <a:buNone/>
             </a:pPr>
             <a:r>
@@ -11084,6 +11660,13 @@
             <a:prstDash val="solid"/>
           </a:ln>
         </p:spPr>
+        <p:txBody>
+          <a:bodyPr/>
+          <a:lstStyle/>
+          <a:p>
+            <a:endParaRPr lang="es-CO"/>
+          </a:p>
+        </p:txBody>
       </p:sp>
       <p:sp>
         <p:nvSpPr>
@@ -11109,6 +11692,13 @@
             <a:prstDash val="solid"/>
           </a:ln>
         </p:spPr>
+        <p:txBody>
+          <a:bodyPr/>
+          <a:lstStyle/>
+          <a:p>
+            <a:endParaRPr lang="es-CO"/>
+          </a:p>
+        </p:txBody>
       </p:sp>
       <p:sp>
         <p:nvSpPr>
@@ -11134,6 +11724,13 @@
             <a:prstDash val="solid"/>
           </a:ln>
         </p:spPr>
+        <p:txBody>
+          <a:bodyPr/>
+          <a:lstStyle/>
+          <a:p>
+            <a:endParaRPr lang="es-CO"/>
+          </a:p>
+        </p:txBody>
       </p:sp>
       <p:sp>
         <p:nvSpPr>
@@ -11159,6 +11756,13 @@
             <a:prstDash val="solid"/>
           </a:ln>
         </p:spPr>
+        <p:txBody>
+          <a:bodyPr/>
+          <a:lstStyle/>
+          <a:p>
+            <a:endParaRPr lang="es-CO"/>
+          </a:p>
+        </p:txBody>
       </p:sp>
       <p:sp>
         <p:nvSpPr>
@@ -11181,7 +11785,7 @@
           <a:bodyPr wrap="square" rtlCol="0" anchor="ctr"/>
           <a:lstStyle/>
           <a:p>
-            <a:pPr algn="ctr" indent="0" marL="0">
+            <a:pPr marL="0" indent="0" algn="ctr">
               <a:buNone/>
             </a:pPr>
             <a:r>
@@ -11198,7 +11802,7 @@
             <a:endParaRPr lang="en-US" sz="700" dirty="0"/>
           </a:p>
           <a:p>
-            <a:pPr algn="ctr" indent="0" marL="0">
+            <a:pPr marL="0" indent="0" algn="ctr">
               <a:buNone/>
             </a:pPr>
             <a:r>
@@ -11240,6 +11844,13 @@
             <a:prstDash val="solid"/>
           </a:ln>
         </p:spPr>
+        <p:txBody>
+          <a:bodyPr/>
+          <a:lstStyle/>
+          <a:p>
+            <a:endParaRPr lang="es-CO"/>
+          </a:p>
+        </p:txBody>
       </p:sp>
       <p:sp>
         <p:nvSpPr>
@@ -11262,7 +11873,7 @@
           <a:bodyPr wrap="square" rtlCol="0" anchor="ctr"/>
           <a:lstStyle/>
           <a:p>
-            <a:pPr indent="0" marL="0">
+            <a:pPr marL="0" indent="0">
               <a:buNone/>
             </a:pPr>
             <a:r>
@@ -11304,6 +11915,13 @@
             <a:prstDash val="solid"/>
           </a:ln>
         </p:spPr>
+        <p:txBody>
+          <a:bodyPr/>
+          <a:lstStyle/>
+          <a:p>
+            <a:endParaRPr lang="es-CO"/>
+          </a:p>
+        </p:txBody>
       </p:sp>
       <p:sp>
         <p:nvSpPr>
@@ -11326,7 +11944,7 @@
           <a:bodyPr wrap="square" rtlCol="0" anchor="ctr"/>
           <a:lstStyle/>
           <a:p>
-            <a:pPr indent="0" marL="0">
+            <a:pPr marL="0" indent="0">
               <a:buNone/>
             </a:pPr>
             <a:r>
@@ -11368,6 +11986,13 @@
             <a:prstDash val="solid"/>
           </a:ln>
         </p:spPr>
+        <p:txBody>
+          <a:bodyPr/>
+          <a:lstStyle/>
+          <a:p>
+            <a:endParaRPr lang="es-CO"/>
+          </a:p>
+        </p:txBody>
       </p:sp>
       <p:sp>
         <p:nvSpPr>
@@ -11390,7 +12015,7 @@
           <a:bodyPr wrap="square" rtlCol="0" anchor="ctr"/>
           <a:lstStyle/>
           <a:p>
-            <a:pPr indent="0" marL="0">
+            <a:pPr marL="0" indent="0">
               <a:buNone/>
             </a:pPr>
             <a:r>
@@ -11432,6 +12057,13 @@
             <a:prstDash val="solid"/>
           </a:ln>
         </p:spPr>
+        <p:txBody>
+          <a:bodyPr/>
+          <a:lstStyle/>
+          <a:p>
+            <a:endParaRPr lang="es-CO"/>
+          </a:p>
+        </p:txBody>
       </p:sp>
       <p:sp>
         <p:nvSpPr>
@@ -11454,7 +12086,7 @@
           <a:bodyPr wrap="square" rtlCol="0" anchor="ctr"/>
           <a:lstStyle/>
           <a:p>
-            <a:pPr indent="0" marL="0">
+            <a:pPr marL="0" indent="0">
               <a:buNone/>
             </a:pPr>
             <a:r>
@@ -11496,6 +12128,13 @@
             <a:prstDash val="solid"/>
           </a:ln>
         </p:spPr>
+        <p:txBody>
+          <a:bodyPr/>
+          <a:lstStyle/>
+          <a:p>
+            <a:endParaRPr lang="es-CO"/>
+          </a:p>
+        </p:txBody>
       </p:sp>
       <p:sp>
         <p:nvSpPr>
@@ -11518,7 +12157,7 @@
           <a:bodyPr wrap="square" rtlCol="0" anchor="ctr"/>
           <a:lstStyle/>
           <a:p>
-            <a:pPr algn="ctr" indent="0" marL="0">
+            <a:pPr marL="0" indent="0" algn="ctr">
               <a:buNone/>
             </a:pPr>
             <a:r>
@@ -11560,6 +12199,13 @@
             <a:prstDash val="solid"/>
           </a:ln>
         </p:spPr>
+        <p:txBody>
+          <a:bodyPr/>
+          <a:lstStyle/>
+          <a:p>
+            <a:endParaRPr lang="es-CO"/>
+          </a:p>
+        </p:txBody>
       </p:sp>
       <p:sp>
         <p:nvSpPr>
@@ -11585,6 +12231,13 @@
             <a:prstDash val="solid"/>
           </a:ln>
         </p:spPr>
+        <p:txBody>
+          <a:bodyPr/>
+          <a:lstStyle/>
+          <a:p>
+            <a:endParaRPr lang="es-CO"/>
+          </a:p>
+        </p:txBody>
       </p:sp>
       <p:sp>
         <p:nvSpPr>
@@ -11607,7 +12260,7 @@
           <a:bodyPr wrap="square" rtlCol="0" anchor="ctr"/>
           <a:lstStyle/>
           <a:p>
-            <a:pPr algn="ctr" indent="0" marL="0">
+            <a:pPr marL="0" indent="0" algn="ctr">
               <a:buNone/>
             </a:pPr>
             <a:r>
@@ -11649,6 +12302,13 @@
             <a:prstDash val="solid"/>
           </a:ln>
         </p:spPr>
+        <p:txBody>
+          <a:bodyPr/>
+          <a:lstStyle/>
+          <a:p>
+            <a:endParaRPr lang="es-CO"/>
+          </a:p>
+        </p:txBody>
       </p:sp>
       <p:sp>
         <p:nvSpPr>
@@ -11671,7 +12331,7 @@
           <a:bodyPr wrap="square" rtlCol="0" anchor="ctr"/>
           <a:lstStyle/>
           <a:p>
-            <a:pPr algn="ctr" indent="0" marL="0">
+            <a:pPr marL="0" indent="0" algn="ctr">
               <a:buNone/>
             </a:pPr>
             <a:r>
@@ -11713,6 +12373,13 @@
             <a:prstDash val="solid"/>
           </a:ln>
         </p:spPr>
+        <p:txBody>
+          <a:bodyPr/>
+          <a:lstStyle/>
+          <a:p>
+            <a:endParaRPr lang="es-CO"/>
+          </a:p>
+        </p:txBody>
       </p:sp>
       <p:sp>
         <p:nvSpPr>
@@ -11735,7 +12402,7 @@
           <a:bodyPr wrap="square" rtlCol="0" anchor="ctr"/>
           <a:lstStyle/>
           <a:p>
-            <a:pPr algn="ctr" indent="0" marL="0">
+            <a:pPr marL="0" indent="0" algn="ctr">
               <a:buNone/>
             </a:pPr>
             <a:r>
@@ -11777,6 +12444,13 @@
             <a:prstDash val="solid"/>
           </a:ln>
         </p:spPr>
+        <p:txBody>
+          <a:bodyPr/>
+          <a:lstStyle/>
+          <a:p>
+            <a:endParaRPr lang="es-CO"/>
+          </a:p>
+        </p:txBody>
       </p:sp>
       <p:sp>
         <p:nvSpPr>
@@ -11799,7 +12473,7 @@
           <a:bodyPr wrap="square" rtlCol="0" anchor="ctr"/>
           <a:lstStyle/>
           <a:p>
-            <a:pPr algn="ctr" indent="0" marL="0">
+            <a:pPr marL="0" indent="0" algn="ctr">
               <a:buNone/>
             </a:pPr>
             <a:r>
@@ -11866,6 +12540,13 @@
             <a:prstDash val="solid"/>
           </a:ln>
         </p:spPr>
+        <p:txBody>
+          <a:bodyPr/>
+          <a:lstStyle/>
+          <a:p>
+            <a:endParaRPr lang="es-CO"/>
+          </a:p>
+        </p:txBody>
       </p:sp>
       <p:sp>
         <p:nvSpPr>
@@ -11888,7 +12569,7 @@
           <a:bodyPr wrap="square" lIns="0" tIns="0" rIns="0" bIns="0" rtlCol="0" anchor="ctr"/>
           <a:lstStyle/>
           <a:p>
-            <a:pPr indent="0" marL="0">
+            <a:pPr marL="0" indent="0">
               <a:buNone/>
             </a:pPr>
             <a:r>
@@ -11930,6 +12611,13 @@
             <a:prstDash val="solid"/>
           </a:ln>
         </p:spPr>
+        <p:txBody>
+          <a:bodyPr/>
+          <a:lstStyle/>
+          <a:p>
+            <a:endParaRPr lang="es-CO"/>
+          </a:p>
+        </p:txBody>
       </p:sp>
       <p:sp>
         <p:nvSpPr>
@@ -11955,6 +12643,13 @@
             <a:prstDash val="solid"/>
           </a:ln>
         </p:spPr>
+        <p:txBody>
+          <a:bodyPr/>
+          <a:lstStyle/>
+          <a:p>
+            <a:endParaRPr lang="es-CO"/>
+          </a:p>
+        </p:txBody>
       </p:sp>
       <p:sp>
         <p:nvSpPr>
@@ -11977,7 +12672,7 @@
           <a:bodyPr wrap="square" rtlCol="0" anchor="ctr"/>
           <a:lstStyle/>
           <a:p>
-            <a:pPr indent="0" marL="0">
+            <a:pPr marL="0" indent="0">
               <a:buNone/>
             </a:pPr>
             <a:r>
@@ -12019,6 +12714,13 @@
             <a:prstDash val="solid"/>
           </a:ln>
         </p:spPr>
+        <p:txBody>
+          <a:bodyPr/>
+          <a:lstStyle/>
+          <a:p>
+            <a:endParaRPr lang="es-CO"/>
+          </a:p>
+        </p:txBody>
       </p:sp>
       <p:sp>
         <p:nvSpPr>
@@ -12041,7 +12743,7 @@
           <a:bodyPr wrap="square" lIns="0" tIns="0" rIns="0" bIns="0" rtlCol="0" anchor="ctr"/>
           <a:lstStyle/>
           <a:p>
-            <a:pPr indent="0" marL="0">
+            <a:pPr marL="0" indent="0">
               <a:buNone/>
             </a:pPr>
             <a:r>
@@ -12080,7 +12782,7 @@
           <a:bodyPr wrap="square" lIns="0" tIns="0" rIns="0" bIns="0" rtlCol="0" anchor="ctr"/>
           <a:lstStyle/>
           <a:p>
-            <a:pPr indent="0" marL="0">
+            <a:pPr marL="0" indent="0">
               <a:buNone/>
             </a:pPr>
             <a:r>
@@ -12119,7 +12821,7 @@
           <a:bodyPr wrap="square" lIns="0" tIns="0" rIns="0" bIns="0" rtlCol="0" anchor="ctr"/>
           <a:lstStyle/>
           <a:p>
-            <a:pPr indent="0" marL="0">
+            <a:pPr marL="0" indent="0">
               <a:buNone/>
             </a:pPr>
             <a:r>
@@ -12158,7 +12860,7 @@
           <a:bodyPr wrap="square" lIns="0" tIns="0" rIns="0" bIns="0" rtlCol="0" anchor="ctr"/>
           <a:lstStyle/>
           <a:p>
-            <a:pPr indent="0" marL="0">
+            <a:pPr marL="0" indent="0">
               <a:buNone/>
             </a:pPr>
             <a:r>
@@ -12197,7 +12899,7 @@
           <a:bodyPr wrap="square" lIns="0" tIns="0" rIns="0" bIns="0" rtlCol="0" anchor="ctr"/>
           <a:lstStyle/>
           <a:p>
-            <a:pPr indent="0" marL="0">
+            <a:pPr marL="0" indent="0">
               <a:buNone/>
             </a:pPr>
             <a:r>
@@ -12236,7 +12938,7 @@
           <a:bodyPr wrap="square" lIns="0" tIns="0" rIns="0" bIns="0" rtlCol="0" anchor="ctr"/>
           <a:lstStyle/>
           <a:p>
-            <a:pPr indent="0" marL="0">
+            <a:pPr marL="0" indent="0">
               <a:buNone/>
             </a:pPr>
             <a:r>
@@ -12275,7 +12977,7 @@
           <a:bodyPr wrap="square" lIns="0" tIns="0" rIns="0" bIns="0" rtlCol="0" anchor="ctr"/>
           <a:lstStyle/>
           <a:p>
-            <a:pPr indent="0" marL="0">
+            <a:pPr marL="0" indent="0">
               <a:buNone/>
             </a:pPr>
             <a:r>
@@ -12314,7 +13016,7 @@
           <a:bodyPr wrap="square" lIns="0" tIns="0" rIns="0" bIns="0" rtlCol="0" anchor="ctr"/>
           <a:lstStyle/>
           <a:p>
-            <a:pPr indent="0" marL="0">
+            <a:pPr marL="0" indent="0">
               <a:buNone/>
             </a:pPr>
             <a:r>
@@ -12353,7 +13055,7 @@
           <a:bodyPr wrap="square" lIns="0" tIns="0" rIns="0" bIns="0" rtlCol="0" anchor="ctr"/>
           <a:lstStyle/>
           <a:p>
-            <a:pPr indent="0" marL="0">
+            <a:pPr marL="0" indent="0">
               <a:buNone/>
             </a:pPr>
             <a:r>
@@ -12392,7 +13094,7 @@
           <a:bodyPr wrap="square" lIns="0" tIns="0" rIns="0" bIns="0" rtlCol="0" anchor="ctr"/>
           <a:lstStyle/>
           <a:p>
-            <a:pPr indent="0" marL="0">
+            <a:pPr marL="0" indent="0">
               <a:buNone/>
             </a:pPr>
             <a:r>
@@ -12431,7 +13133,7 @@
           <a:bodyPr wrap="square" lIns="0" tIns="0" rIns="0" bIns="0" rtlCol="0" anchor="ctr"/>
           <a:lstStyle/>
           <a:p>
-            <a:pPr indent="0" marL="0">
+            <a:pPr marL="0" indent="0">
               <a:buNone/>
             </a:pPr>
             <a:r>
@@ -12470,7 +13172,7 @@
           <a:bodyPr wrap="square" lIns="0" tIns="0" rIns="0" bIns="0" rtlCol="0" anchor="ctr"/>
           <a:lstStyle/>
           <a:p>
-            <a:pPr indent="0" marL="0">
+            <a:pPr marL="0" indent="0">
               <a:buNone/>
             </a:pPr>
             <a:r>
@@ -12509,7 +13211,7 @@
           <a:bodyPr wrap="square" lIns="0" tIns="0" rIns="0" bIns="0" rtlCol="0" anchor="ctr"/>
           <a:lstStyle/>
           <a:p>
-            <a:pPr indent="0" marL="0">
+            <a:pPr marL="0" indent="0">
               <a:buNone/>
             </a:pPr>
             <a:r>
@@ -12548,7 +13250,7 @@
           <a:bodyPr wrap="square" lIns="0" tIns="0" rIns="0" bIns="0" rtlCol="0" anchor="ctr"/>
           <a:lstStyle/>
           <a:p>
-            <a:pPr indent="0" marL="0">
+            <a:pPr marL="0" indent="0">
               <a:buNone/>
             </a:pPr>
             <a:r>
@@ -12867,4 +13569,319 @@
     </a:ext>
   </a:extLst>
 </a:theme>
+</file>
+
+<file path=ppt/theme/theme2.xml><?xml version="1.0" encoding="utf-8"?>
+<a:theme xmlns:a="http://schemas.openxmlformats.org/drawingml/2006/main" name="Tema de Office">
+  <a:themeElements>
+    <a:clrScheme name="Office">
+      <a:dk1>
+        <a:sysClr val="windowText" lastClr="000000"/>
+      </a:dk1>
+      <a:lt1>
+        <a:sysClr val="window" lastClr="FFFFFF"/>
+      </a:lt1>
+      <a:dk2>
+        <a:srgbClr val="0E2841"/>
+      </a:dk2>
+      <a:lt2>
+        <a:srgbClr val="E8E8E8"/>
+      </a:lt2>
+      <a:accent1>
+        <a:srgbClr val="156082"/>
+      </a:accent1>
+      <a:accent2>
+        <a:srgbClr val="E97132"/>
+      </a:accent2>
+      <a:accent3>
+        <a:srgbClr val="196B24"/>
+      </a:accent3>
+      <a:accent4>
+        <a:srgbClr val="0F9ED5"/>
+      </a:accent4>
+      <a:accent5>
+        <a:srgbClr val="A02B93"/>
+      </a:accent5>
+      <a:accent6>
+        <a:srgbClr val="4EA72E"/>
+      </a:accent6>
+      <a:hlink>
+        <a:srgbClr val="467886"/>
+      </a:hlink>
+      <a:folHlink>
+        <a:srgbClr val="96607D"/>
+      </a:folHlink>
+    </a:clrScheme>
+    <a:fontScheme name="Office">
+      <a:majorFont>
+        <a:latin typeface="Aptos Display" panose="02110004020202020204"/>
+        <a:ea typeface=""/>
+        <a:cs typeface=""/>
+        <a:font script="Jpan" typeface="游ゴシック Light"/>
+        <a:font script="Hang" typeface="맑은 고딕"/>
+        <a:font script="Hans" typeface="等线 Light"/>
+        <a:font script="Hant" typeface="新細明體"/>
+        <a:font script="Arab" typeface="Times New Roman"/>
+        <a:font script="Hebr" typeface="Times New Roman"/>
+        <a:font script="Thai" typeface="Angsana New"/>
+        <a:font script="Ethi" typeface="Nyala"/>
+        <a:font script="Beng" typeface="Vrinda"/>
+        <a:font script="Gujr" typeface="Shruti"/>
+        <a:font script="Khmr" typeface="MoolBoran"/>
+        <a:font script="Knda" typeface="Tunga"/>
+        <a:font script="Guru" typeface="Raavi"/>
+        <a:font script="Cans" typeface="Euphemia"/>
+        <a:font script="Cher" typeface="Plantagenet Cherokee"/>
+        <a:font script="Yiii" typeface="Microsoft Yi Baiti"/>
+        <a:font script="Tibt" typeface="Microsoft Himalaya"/>
+        <a:font script="Thaa" typeface="MV Boli"/>
+        <a:font script="Deva" typeface="Mangal"/>
+        <a:font script="Telu" typeface="Gautami"/>
+        <a:font script="Taml" typeface="Latha"/>
+        <a:font script="Syrc" typeface="Estrangelo Edessa"/>
+        <a:font script="Orya" typeface="Kalinga"/>
+        <a:font script="Mlym" typeface="Kartika"/>
+        <a:font script="Laoo" typeface="DokChampa"/>
+        <a:font script="Sinh" typeface="Iskoola Pota"/>
+        <a:font script="Mong" typeface="Mongolian Baiti"/>
+        <a:font script="Viet" typeface="Times New Roman"/>
+        <a:font script="Uigh" typeface="Microsoft Uighur"/>
+        <a:font script="Geor" typeface="Sylfaen"/>
+        <a:font script="Armn" typeface="Arial"/>
+        <a:font script="Bugi" typeface="Leelawadee UI"/>
+        <a:font script="Bopo" typeface="Microsoft JhengHei"/>
+        <a:font script="Java" typeface="Javanese Text"/>
+        <a:font script="Lisu" typeface="Segoe UI"/>
+        <a:font script="Mymr" typeface="Myanmar Text"/>
+        <a:font script="Nkoo" typeface="Ebrima"/>
+        <a:font script="Olck" typeface="Nirmala UI"/>
+        <a:font script="Osma" typeface="Ebrima"/>
+        <a:font script="Phag" typeface="Phagspa"/>
+        <a:font script="Syrn" typeface="Estrangelo Edessa"/>
+        <a:font script="Syrj" typeface="Estrangelo Edessa"/>
+        <a:font script="Syre" typeface="Estrangelo Edessa"/>
+        <a:font script="Sora" typeface="Nirmala UI"/>
+        <a:font script="Tale" typeface="Microsoft Tai Le"/>
+        <a:font script="Talu" typeface="Microsoft New Tai Lue"/>
+        <a:font script="Tfng" typeface="Ebrima"/>
+      </a:majorFont>
+      <a:minorFont>
+        <a:latin typeface="Aptos" panose="02110004020202020204"/>
+        <a:ea typeface=""/>
+        <a:cs typeface=""/>
+        <a:font script="Jpan" typeface="游ゴシック"/>
+        <a:font script="Hang" typeface="맑은 고딕"/>
+        <a:font script="Hans" typeface="等线"/>
+        <a:font script="Hant" typeface="新細明體"/>
+        <a:font script="Arab" typeface="Arial"/>
+        <a:font script="Hebr" typeface="Arial"/>
+        <a:font script="Thai" typeface="Cordia New"/>
+        <a:font script="Ethi" typeface="Nyala"/>
+        <a:font script="Beng" typeface="Vrinda"/>
+        <a:font script="Gujr" typeface="Shruti"/>
+        <a:font script="Khmr" typeface="DaunPenh"/>
+        <a:font script="Knda" typeface="Tunga"/>
+        <a:font script="Guru" typeface="Raavi"/>
+        <a:font script="Cans" typeface="Euphemia"/>
+        <a:font script="Cher" typeface="Plantagenet Cherokee"/>
+        <a:font script="Yiii" typeface="Microsoft Yi Baiti"/>
+        <a:font script="Tibt" typeface="Microsoft Himalaya"/>
+        <a:font script="Thaa" typeface="MV Boli"/>
+        <a:font script="Deva" typeface="Mangal"/>
+        <a:font script="Telu" typeface="Gautami"/>
+        <a:font script="Taml" typeface="Latha"/>
+        <a:font script="Syrc" typeface="Estrangelo Edessa"/>
+        <a:font script="Orya" typeface="Kalinga"/>
+        <a:font script="Mlym" typeface="Kartika"/>
+        <a:font script="Laoo" typeface="DokChampa"/>
+        <a:font script="Sinh" typeface="Iskoola Pota"/>
+        <a:font script="Mong" typeface="Mongolian Baiti"/>
+        <a:font script="Viet" typeface="Arial"/>
+        <a:font script="Uigh" typeface="Microsoft Uighur"/>
+        <a:font script="Geor" typeface="Sylfaen"/>
+        <a:font script="Armn" typeface="Arial"/>
+        <a:font script="Bugi" typeface="Leelawadee UI"/>
+        <a:font script="Bopo" typeface="Microsoft JhengHei"/>
+        <a:font script="Java" typeface="Javanese Text"/>
+        <a:font script="Lisu" typeface="Segoe UI"/>
+        <a:font script="Mymr" typeface="Myanmar Text"/>
+        <a:font script="Nkoo" typeface="Ebrima"/>
+        <a:font script="Olck" typeface="Nirmala UI"/>
+        <a:font script="Osma" typeface="Ebrima"/>
+        <a:font script="Phag" typeface="Phagspa"/>
+        <a:font script="Syrn" typeface="Estrangelo Edessa"/>
+        <a:font script="Syrj" typeface="Estrangelo Edessa"/>
+        <a:font script="Syre" typeface="Estrangelo Edessa"/>
+        <a:font script="Sora" typeface="Nirmala UI"/>
+        <a:font script="Tale" typeface="Microsoft Tai Le"/>
+        <a:font script="Talu" typeface="Microsoft New Tai Lue"/>
+        <a:font script="Tfng" typeface="Ebrima"/>
+      </a:minorFont>
+    </a:fontScheme>
+    <a:fmtScheme name="Office">
+      <a:fillStyleLst>
+        <a:solidFill>
+          <a:schemeClr val="phClr"/>
+        </a:solidFill>
+        <a:gradFill rotWithShape="1">
+          <a:gsLst>
+            <a:gs pos="0">
+              <a:schemeClr val="phClr">
+                <a:lumMod val="110000"/>
+                <a:satMod val="105000"/>
+                <a:tint val="67000"/>
+              </a:schemeClr>
+            </a:gs>
+            <a:gs pos="50000">
+              <a:schemeClr val="phClr">
+                <a:lumMod val="105000"/>
+                <a:satMod val="103000"/>
+                <a:tint val="73000"/>
+              </a:schemeClr>
+            </a:gs>
+            <a:gs pos="100000">
+              <a:schemeClr val="phClr">
+                <a:lumMod val="105000"/>
+                <a:satMod val="109000"/>
+                <a:tint val="81000"/>
+              </a:schemeClr>
+            </a:gs>
+          </a:gsLst>
+          <a:lin ang="5400000" scaled="0"/>
+        </a:gradFill>
+        <a:gradFill rotWithShape="1">
+          <a:gsLst>
+            <a:gs pos="0">
+              <a:schemeClr val="phClr">
+                <a:satMod val="103000"/>
+                <a:lumMod val="102000"/>
+                <a:tint val="94000"/>
+              </a:schemeClr>
+            </a:gs>
+            <a:gs pos="50000">
+              <a:schemeClr val="phClr">
+                <a:satMod val="110000"/>
+                <a:lumMod val="100000"/>
+                <a:shade val="100000"/>
+              </a:schemeClr>
+            </a:gs>
+            <a:gs pos="100000">
+              <a:schemeClr val="phClr">
+                <a:lumMod val="99000"/>
+                <a:satMod val="120000"/>
+                <a:shade val="78000"/>
+              </a:schemeClr>
+            </a:gs>
+          </a:gsLst>
+          <a:lin ang="5400000" scaled="0"/>
+        </a:gradFill>
+      </a:fillStyleLst>
+      <a:lnStyleLst>
+        <a:ln w="12700" cap="flat" cmpd="sng" algn="ctr">
+          <a:solidFill>
+            <a:schemeClr val="phClr"/>
+          </a:solidFill>
+          <a:prstDash val="solid"/>
+          <a:miter lim="800000"/>
+        </a:ln>
+        <a:ln w="19050" cap="flat" cmpd="sng" algn="ctr">
+          <a:solidFill>
+            <a:schemeClr val="phClr"/>
+          </a:solidFill>
+          <a:prstDash val="solid"/>
+          <a:miter lim="800000"/>
+        </a:ln>
+        <a:ln w="25400" cap="flat" cmpd="sng" algn="ctr">
+          <a:solidFill>
+            <a:schemeClr val="phClr"/>
+          </a:solidFill>
+          <a:prstDash val="solid"/>
+          <a:miter lim="800000"/>
+        </a:ln>
+      </a:lnStyleLst>
+      <a:effectStyleLst>
+        <a:effectStyle>
+          <a:effectLst/>
+        </a:effectStyle>
+        <a:effectStyle>
+          <a:effectLst/>
+        </a:effectStyle>
+        <a:effectStyle>
+          <a:effectLst>
+            <a:outerShdw blurRad="57150" dist="19050" dir="5400000" algn="ctr" rotWithShape="0">
+              <a:srgbClr val="000000">
+                <a:alpha val="63000"/>
+              </a:srgbClr>
+            </a:outerShdw>
+          </a:effectLst>
+        </a:effectStyle>
+      </a:effectStyleLst>
+      <a:bgFillStyleLst>
+        <a:solidFill>
+          <a:schemeClr val="phClr"/>
+        </a:solidFill>
+        <a:solidFill>
+          <a:schemeClr val="phClr">
+            <a:tint val="95000"/>
+            <a:satMod val="170000"/>
+          </a:schemeClr>
+        </a:solidFill>
+        <a:gradFill rotWithShape="1">
+          <a:gsLst>
+            <a:gs pos="0">
+              <a:schemeClr val="phClr">
+                <a:tint val="93000"/>
+                <a:satMod val="150000"/>
+                <a:shade val="98000"/>
+                <a:lumMod val="102000"/>
+              </a:schemeClr>
+            </a:gs>
+            <a:gs pos="50000">
+              <a:schemeClr val="phClr">
+                <a:tint val="98000"/>
+                <a:satMod val="130000"/>
+                <a:shade val="90000"/>
+                <a:lumMod val="103000"/>
+              </a:schemeClr>
+            </a:gs>
+            <a:gs pos="100000">
+              <a:schemeClr val="phClr">
+                <a:shade val="63000"/>
+                <a:satMod val="120000"/>
+              </a:schemeClr>
+            </a:gs>
+          </a:gsLst>
+          <a:lin ang="5400000" scaled="0"/>
+        </a:gradFill>
+      </a:bgFillStyleLst>
+    </a:fmtScheme>
+  </a:themeElements>
+  <a:objectDefaults>
+    <a:lnDef>
+      <a:spPr/>
+      <a:bodyPr/>
+      <a:lstStyle/>
+      <a:style>
+        <a:lnRef idx="2">
+          <a:schemeClr val="accent1"/>
+        </a:lnRef>
+        <a:fillRef idx="0">
+          <a:schemeClr val="accent1"/>
+        </a:fillRef>
+        <a:effectRef idx="1">
+          <a:schemeClr val="accent1"/>
+        </a:effectRef>
+        <a:fontRef idx="minor">
+          <a:schemeClr val="tx1"/>
+        </a:fontRef>
+      </a:style>
+    </a:lnDef>
+  </a:objectDefaults>
+  <a:extraClrSchemeLst/>
+  <a:extLst>
+    <a:ext uri="{05A4C25C-085E-4340-85A3-A5531E510DB2}">
+      <thm15:themeFamily xmlns:thm15="http://schemas.microsoft.com/office/thememl/2012/main" name="Office Theme" id="{2E142A2C-CD16-42D6-873A-C26D2A0506FA}" vid="{1BDDFF52-6CD6-40A5-AB3C-68EB2F1E4D0A}"/>
+    </a:ext>
+  </a:extLst>
+</a:theme>
 </file>
</xml_diff>